<commit_message>
refine regularzation slides for flow
</commit_message>
<xml_diff>
--- a/slides/05-regularization.pptx
+++ b/slides/05-regularization.pptx
@@ -5,12 +5,12 @@
     <p:sldMasterId id="2147483686" r:id="rId1"/>
   </p:sldMasterIdLst>
   <p:notesMasterIdLst>
-    <p:notesMasterId r:id="rId15"/>
+    <p:notesMasterId r:id="rId19"/>
   </p:notesMasterIdLst>
   <p:sldIdLst>
     <p:sldId id="256" r:id="rId2"/>
-    <p:sldId id="274" r:id="rId3"/>
-    <p:sldId id="307" r:id="rId4"/>
+    <p:sldId id="307" r:id="rId3"/>
+    <p:sldId id="274" r:id="rId4"/>
     <p:sldId id="275" r:id="rId5"/>
     <p:sldId id="276" r:id="rId6"/>
     <p:sldId id="277" r:id="rId7"/>
@@ -19,8 +19,12 @@
     <p:sldId id="281" r:id="rId10"/>
     <p:sldId id="306" r:id="rId11"/>
     <p:sldId id="285" r:id="rId12"/>
-    <p:sldId id="287" r:id="rId13"/>
-    <p:sldId id="288" r:id="rId14"/>
+    <p:sldId id="288" r:id="rId13"/>
+    <p:sldId id="287" r:id="rId14"/>
+    <p:sldId id="310" r:id="rId15"/>
+    <p:sldId id="309" r:id="rId16"/>
+    <p:sldId id="311" r:id="rId17"/>
+    <p:sldId id="308" r:id="rId18"/>
   </p:sldIdLst>
   <p:sldSz cx="12192000" cy="6858000"/>
   <p:notesSz cx="6858000" cy="9144000"/>
@@ -524,401 +528,124 @@
           <a:lstStyle/>
           <a:p>
             <a:r>
+              <a:rPr lang="en-US"/>
+              <a:t>Talking points:</a:t>
+            </a:r>
+          </a:p>
+          <a:p>
+            <a:r>
+              <a:rPr lang="en-US"/>
+              <a:t>Start with the three-panel figure</a:t>
+            </a:r>
+            <a:r>
               <a:rPr lang="en-US" dirty="0"/>
-              <a:t>import </a:t>
-            </a:r>
-            <a:r>
-              <a:rPr lang="en-US" dirty="0" err="1"/>
-              <a:t>numpy</a:t>
+              <a:t>: </a:t>
+            </a:r>
+            <a:r>
+              <a:rPr lang="en-US"/>
+              <a:t>same data</a:t>
             </a:r>
             <a:r>
               <a:rPr lang="en-US" dirty="0"/>
-              <a:t> as </a:t>
-            </a:r>
-            <a:r>
-              <a:rPr lang="en-US" dirty="0" err="1"/>
-              <a:t>npimport</a:t>
-            </a:r>
-            <a:r>
-              <a:rPr lang="en-US" dirty="0"/>
-              <a:t> </a:t>
-            </a:r>
-            <a:r>
-              <a:rPr lang="en-US" dirty="0" err="1"/>
-              <a:t>matplotlib.pyplot</a:t>
-            </a:r>
-            <a:r>
-              <a:rPr lang="en-US" dirty="0"/>
-              <a:t> as </a:t>
-            </a:r>
-            <a:r>
-              <a:rPr lang="en-US" dirty="0" err="1"/>
-              <a:t>pltfrom</a:t>
-            </a:r>
-            <a:r>
-              <a:rPr lang="en-US" dirty="0"/>
-              <a:t> </a:t>
-            </a:r>
-            <a:r>
-              <a:rPr lang="en-US" dirty="0" err="1"/>
-              <a:t>pathlib</a:t>
-            </a:r>
-            <a:r>
-              <a:rPr lang="en-US" dirty="0"/>
-              <a:t> import </a:t>
-            </a:r>
-            <a:r>
-              <a:rPr lang="en-US" dirty="0" err="1"/>
-              <a:t>Pathrng</a:t>
-            </a:r>
-            <a:r>
-              <a:rPr lang="en-US" dirty="0"/>
-              <a:t> = </a:t>
-            </a:r>
-            <a:r>
-              <a:rPr lang="en-US" dirty="0" err="1"/>
-              <a:t>np.random.default_rng</a:t>
-            </a:r>
-            <a:r>
-              <a:rPr lang="en-US" dirty="0"/>
-              <a:t>(7)x = </a:t>
-            </a:r>
-            <a:r>
-              <a:rPr lang="en-US" dirty="0" err="1"/>
-              <a:t>np.linspace</a:t>
-            </a:r>
-            <a:r>
-              <a:rPr lang="en-US" dirty="0"/>
-              <a:t>(0, 10, 22)</a:t>
-            </a:r>
-            <a:r>
-              <a:rPr lang="en-US" dirty="0" err="1"/>
-              <a:t>true_function</a:t>
-            </a:r>
-            <a:r>
-              <a:rPr lang="en-US" dirty="0"/>
-              <a:t> = lambda x: 0.12 * (x - 5)**2 + 0.5 * </a:t>
-            </a:r>
-            <a:r>
-              <a:rPr lang="en-US" dirty="0" err="1"/>
-              <a:t>np.sin</a:t>
-            </a:r>
-            <a:r>
-              <a:rPr lang="en-US" dirty="0"/>
-              <a:t>(1.1 * x) + 2y = </a:t>
-            </a:r>
-            <a:r>
-              <a:rPr lang="en-US" dirty="0" err="1"/>
-              <a:t>true_function</a:t>
-            </a:r>
-            <a:r>
-              <a:rPr lang="en-US" dirty="0"/>
-              <a:t>(x) + </a:t>
-            </a:r>
-            <a:r>
-              <a:rPr lang="en-US" dirty="0" err="1"/>
-              <a:t>rng.normal</a:t>
-            </a:r>
-            <a:r>
-              <a:rPr lang="en-US" dirty="0"/>
-              <a:t>(0, 0.45, size=</a:t>
-            </a:r>
-            <a:r>
-              <a:rPr lang="en-US" dirty="0" err="1"/>
-              <a:t>x.size</a:t>
-            </a:r>
-            <a:r>
-              <a:rPr lang="en-US" dirty="0"/>
-              <a:t>)</a:t>
-            </a:r>
-            <a:r>
-              <a:rPr lang="en-US" dirty="0" err="1"/>
-              <a:t>x_grid</a:t>
-            </a:r>
-            <a:r>
-              <a:rPr lang="en-US" dirty="0"/>
-              <a:t> = </a:t>
-            </a:r>
-            <a:r>
-              <a:rPr lang="en-US" dirty="0" err="1"/>
-              <a:t>np.linspace</a:t>
-            </a:r>
-            <a:r>
-              <a:rPr lang="en-US" dirty="0"/>
-              <a:t>(0, 10, 800)models = [    ("Underfitting", 1),    ("Good fit", 4),    ("Overfitting", 18),]fig, axes = </a:t>
-            </a:r>
-            <a:r>
-              <a:rPr lang="en-US" dirty="0" err="1"/>
-              <a:t>plt.subplots</a:t>
-            </a:r>
-            <a:r>
-              <a:rPr lang="en-US" dirty="0"/>
-              <a:t>(1, 3, </a:t>
-            </a:r>
-            <a:r>
-              <a:rPr lang="en-US" dirty="0" err="1"/>
-              <a:t>figsize</a:t>
-            </a:r>
-            <a:r>
-              <a:rPr lang="en-US" dirty="0"/>
-              <a:t>=(14, 4.8), </a:t>
-            </a:r>
-            <a:r>
-              <a:rPr lang="en-US" dirty="0" err="1"/>
-              <a:t>sharex</a:t>
-            </a:r>
-            <a:r>
-              <a:rPr lang="en-US" dirty="0"/>
-              <a:t>=True, </a:t>
-            </a:r>
-            <a:r>
-              <a:rPr lang="en-US" dirty="0" err="1"/>
-              <a:t>sharey</a:t>
-            </a:r>
-            <a:r>
-              <a:rPr lang="en-US" dirty="0"/>
-              <a:t>=True)for ax, (title, degree) in zip(axes, models):    </a:t>
-            </a:r>
-            <a:r>
-              <a:rPr lang="en-US" dirty="0" err="1"/>
-              <a:t>coeffs</a:t>
-            </a:r>
-            <a:r>
-              <a:rPr lang="en-US" dirty="0"/>
-              <a:t> = </a:t>
-            </a:r>
-            <a:r>
-              <a:rPr lang="en-US" dirty="0" err="1"/>
-              <a:t>np.polyfit</a:t>
-            </a:r>
-            <a:r>
-              <a:rPr lang="en-US" dirty="0"/>
-              <a:t>(x, y, degree)    </a:t>
-            </a:r>
-            <a:r>
-              <a:rPr lang="en-US" dirty="0" err="1"/>
-              <a:t>y_grid</a:t>
-            </a:r>
-            <a:r>
-              <a:rPr lang="en-US" dirty="0"/>
-              <a:t> = </a:t>
-            </a:r>
-            <a:r>
-              <a:rPr lang="en-US" dirty="0" err="1"/>
-              <a:t>np.polyval</a:t>
+              <a:t>, </a:t>
+            </a:r>
+            <a:r>
+              <a:rPr lang="en-US"/>
+              <a:t>three model complexities.</a:t>
+            </a:r>
+          </a:p>
+          <a:p>
+            <a:r>
+              <a:rPr lang="en-US"/>
+              <a:t>Underfit </a:t>
             </a:r>
             <a:r>
               <a:rPr lang="en-US" dirty="0"/>
               <a:t>(</a:t>
             </a:r>
             <a:r>
-              <a:rPr lang="en-US" dirty="0" err="1"/>
-              <a:t>coeffs</a:t>
+              <a:rPr lang="en-US"/>
+              <a:t>degree 1): the model is too rigid — high bias</a:t>
             </a:r>
             <a:r>
               <a:rPr lang="en-US" dirty="0"/>
               <a:t>, </a:t>
             </a:r>
             <a:r>
-              <a:rPr lang="en-US" dirty="0" err="1"/>
-              <a:t>x_grid</a:t>
-            </a:r>
+              <a:rPr lang="en-US"/>
+              <a:t>misses the curvature.</a:t>
+            </a:r>
+          </a:p>
+          <a:p>
             <a:r>
               <a:rPr lang="en-US" dirty="0"/>
-              <a:t>)    </a:t>
-            </a:r>
-            <a:r>
-              <a:rPr lang="en-US" dirty="0" err="1"/>
-              <a:t>ax.scatter</a:t>
+              <a:t>Good fit (degree</a:t>
+            </a:r>
+            <a:r>
+              <a:rPr lang="en-US"/>
+              <a:t> 4</a:t>
             </a:r>
             <a:r>
               <a:rPr lang="en-US" dirty="0"/>
-              <a:t>(        x, y,        s=48,        </a:t>
-            </a:r>
-            <a:r>
-              <a:rPr lang="en-US" dirty="0" err="1"/>
-              <a:t>facecolors</a:t>
+              <a:t>): </a:t>
+            </a:r>
+            <a:r>
+              <a:rPr lang="en-US"/>
+              <a:t>captures the signal without chasing noise.</a:t>
+            </a:r>
+          </a:p>
+          <a:p>
+            <a:r>
+              <a:rPr lang="en-US"/>
+              <a:t>Overfit </a:t>
             </a:r>
             <a:r>
               <a:rPr lang="en-US" dirty="0"/>
-              <a:t>="white",        </a:t>
-            </a:r>
-            <a:r>
-              <a:rPr lang="en-US" dirty="0" err="1"/>
-              <a:t>edgecolors</a:t>
+              <a:t>(degree</a:t>
+            </a:r>
+            <a:r>
+              <a:rPr lang="en-US"/>
+              <a:t> 18): passes near every point but will generalize terribly to new data.</a:t>
+            </a:r>
+          </a:p>
+          <a:p>
+            <a:r>
+              <a:rPr lang="en-US"/>
+              <a:t>Ask the class: which model has the lowest training error? </a:t>
             </a:r>
             <a:r>
               <a:rPr lang="en-US" dirty="0"/>
-              <a:t>="black",        linewidths=1.2,        </a:t>
-            </a:r>
-            <a:r>
-              <a:rPr lang="en-US" dirty="0" err="1"/>
-              <a:t>zorder</a:t>
+              <a:t>(</a:t>
+            </a:r>
+            <a:r>
+              <a:rPr lang="en-US"/>
+              <a:t>The overfit one.) That is exactly why training error alone is a bad model-selection criterion.</a:t>
+            </a:r>
+          </a:p>
+          <a:p>
+            <a:r>
+              <a:rPr lang="en-US"/>
+              <a:t>Bridge: regularization gives us a dial between these extremes without having to guess the right polynomial </a:t>
             </a:r>
             <a:r>
               <a:rPr lang="en-US" dirty="0"/>
-              <a:t>=4,    )    </a:t>
-            </a:r>
-            <a:r>
-              <a:rPr lang="en-US" dirty="0" err="1"/>
-              <a:t>ax.plot</a:t>
-            </a:r>
+              <a:t>degree</a:t>
+            </a:r>
+            <a:r>
+              <a:rPr lang="en-US"/>
+              <a:t>.</a:t>
+            </a:r>
+          </a:p>
+          <a:p>
             <a:r>
               <a:rPr lang="en-US" dirty="0"/>
-              <a:t>(        </a:t>
-            </a:r>
-            <a:r>
-              <a:rPr lang="en-US" dirty="0" err="1"/>
-              <a:t>x_grid</a:t>
-            </a:r>
-            <a:r>
-              <a:rPr lang="en-US" dirty="0"/>
-              <a:t>, </a:t>
-            </a:r>
-            <a:r>
-              <a:rPr lang="en-US" dirty="0" err="1"/>
-              <a:t>y_grid</a:t>
-            </a:r>
-            <a:r>
-              <a:rPr lang="en-US" dirty="0"/>
-              <a:t>,        linewidth=2.5,        </a:t>
-            </a:r>
-            <a:r>
-              <a:rPr lang="en-US" dirty="0" err="1"/>
-              <a:t>zorder</a:t>
-            </a:r>
-            <a:r>
-              <a:rPr lang="en-US" dirty="0"/>
-              <a:t>=3,    )    </a:t>
-            </a:r>
-            <a:r>
-              <a:rPr lang="en-US" dirty="0" err="1"/>
-              <a:t>ax.set_title</a:t>
-            </a:r>
-            <a:r>
-              <a:rPr lang="en-US" dirty="0"/>
-              <a:t>(f"{title}\</a:t>
-            </a:r>
-            <a:r>
-              <a:rPr lang="en-US" dirty="0" err="1"/>
-              <a:t>nPolynomial</a:t>
-            </a:r>
-            <a:r>
-              <a:rPr lang="en-US" dirty="0"/>
-              <a:t> degree = {degree}", </a:t>
-            </a:r>
-            <a:r>
-              <a:rPr lang="en-US" dirty="0" err="1"/>
-              <a:t>fontsize</a:t>
-            </a:r>
-            <a:r>
-              <a:rPr lang="en-US" dirty="0"/>
-              <a:t>=13, pad=10)    </a:t>
-            </a:r>
-            <a:r>
-              <a:rPr lang="en-US" dirty="0" err="1"/>
-              <a:t>ax.set_xlabel</a:t>
-            </a:r>
-            <a:r>
-              <a:rPr lang="en-US" dirty="0"/>
-              <a:t>("$x$", </a:t>
-            </a:r>
-            <a:r>
-              <a:rPr lang="en-US" dirty="0" err="1"/>
-              <a:t>fontsize</a:t>
-            </a:r>
-            <a:r>
-              <a:rPr lang="en-US" dirty="0"/>
-              <a:t>=12)    </a:t>
-            </a:r>
-            <a:r>
-              <a:rPr lang="en-US" dirty="0" err="1"/>
-              <a:t>ax.grid</a:t>
-            </a:r>
-            <a:r>
-              <a:rPr lang="en-US" dirty="0"/>
-              <a:t>(alpha=0.18)axes[0].</a:t>
-            </a:r>
-            <a:r>
-              <a:rPr lang="en-US" dirty="0" err="1"/>
-              <a:t>set_ylabel</a:t>
-            </a:r>
-            <a:r>
-              <a:rPr lang="en-US" dirty="0"/>
-              <a:t>("$y$", </a:t>
-            </a:r>
-            <a:r>
-              <a:rPr lang="en-US" dirty="0" err="1"/>
-              <a:t>fontsize</a:t>
-            </a:r>
-            <a:r>
-              <a:rPr lang="en-US" dirty="0"/>
-              <a:t>=12)</a:t>
-            </a:r>
-            <a:r>
-              <a:rPr lang="en-US" dirty="0" err="1"/>
-              <a:t>fig.suptitle</a:t>
-            </a:r>
-            <a:r>
-              <a:rPr lang="en-US" dirty="0"/>
-              <a:t>(    "Polynomial Regression: Underfitting vs. Good Fit vs. Overfitting",    </a:t>
-            </a:r>
-            <a:r>
-              <a:rPr lang="en-US" dirty="0" err="1"/>
-              <a:t>fontsize</a:t>
-            </a:r>
-            <a:r>
-              <a:rPr lang="en-US" dirty="0"/>
-              <a:t>=16,    y=1.03,)axes[0].</a:t>
-            </a:r>
-            <a:r>
-              <a:rPr lang="en-US" dirty="0" err="1"/>
-              <a:t>set_xlim</a:t>
-            </a:r>
-            <a:r>
-              <a:rPr lang="en-US" dirty="0"/>
-              <a:t>(-0.3, 10.3)axes[0].</a:t>
-            </a:r>
-            <a:r>
-              <a:rPr lang="en-US" dirty="0" err="1"/>
-              <a:t>set_ylim</a:t>
-            </a:r>
-            <a:r>
-              <a:rPr lang="en-US" dirty="0"/>
-              <a:t>(-1.0, 5.5)</a:t>
-            </a:r>
-            <a:r>
-              <a:rPr lang="en-US" dirty="0" err="1"/>
-              <a:t>fig.tight_layout</a:t>
-            </a:r>
-            <a:r>
-              <a:rPr lang="en-US" dirty="0"/>
-              <a:t>()</a:t>
-            </a:r>
-            <a:r>
-              <a:rPr lang="en-US" dirty="0" err="1"/>
-              <a:t>plt.savefig</a:t>
-            </a:r>
-            <a:r>
-              <a:rPr lang="en-US" dirty="0"/>
-              <a:t>("polynomial_regression_three_subplots.png", dpi=220, </a:t>
-            </a:r>
-            <a:r>
-              <a:rPr lang="en-US" dirty="0" err="1"/>
-              <a:t>bbox_inches</a:t>
-            </a:r>
-            <a:r>
-              <a:rPr lang="en-US" dirty="0"/>
-              <a:t>="tight")</a:t>
-            </a:r>
-            <a:r>
-              <a:rPr lang="en-US" dirty="0" err="1"/>
-              <a:t>plt.show</a:t>
-            </a:r>
-            <a:r>
-              <a:rPr lang="en-US" dirty="0"/>
-              <a:t>()</a:t>
-            </a:r>
+              <a:t>(</a:t>
+            </a:r>
+            <a:r>
+              <a:rPr lang="en-US"/>
+              <a:t>Figure generated with a short matplotlib script; source available in the course repo.)</a:t>
+            </a:r>
+            <a:endParaRPr lang="en-US" dirty="0"/>
           </a:p>
         </p:txBody>
       </p:sp>
@@ -939,7 +666,7 @@
           <a:p>
             <a:fld id="{98F0E3D6-3C77-45F1-B7E2-5B66F3D24A72}" type="slidenum">
               <a:rPr lang="en-US" smtClean="0"/>
-              <a:t>3</a:t>
+              <a:t>2</a:t>
             </a:fld>
             <a:endParaRPr lang="en-US"/>
           </a:p>
@@ -5128,7 +4855,7 @@
         <p:spPr>
           <a:xfrm>
             <a:off x="750367" y="826603"/>
-            <a:ext cx="10691265" cy="1307592"/>
+            <a:ext cx="10691265" cy="822960"/>
           </a:xfrm>
           <a:prstGeom prst="rect">
             <a:avLst/>
@@ -5162,8 +4889,8 @@
         </p:nvSpPr>
         <p:spPr>
           <a:xfrm>
-            <a:off x="1750264" y="6308092"/>
-            <a:ext cx="7727111" cy="646331"/>
+            <a:off x="1750264" y="6035040"/>
+            <a:ext cx="7727111" cy="640080"/>
           </a:xfrm>
           <a:prstGeom prst="rect">
             <a:avLst/>
@@ -5218,8 +4945,8 @@
         </p:blipFill>
         <p:spPr bwMode="auto">
           <a:xfrm>
-            <a:off x="3016547" y="1360286"/>
-            <a:ext cx="5014643" cy="5086465"/>
+            <a:off x="3429000" y="1691640"/>
+            <a:ext cx="4142232" cy="4206240"/>
           </a:xfrm>
           <a:prstGeom prst="rect">
             <a:avLst/>
@@ -5250,7 +4977,7 @@
         </p:nvSpPr>
         <p:spPr>
           <a:xfrm>
-            <a:off x="8393502" y="1751161"/>
+            <a:off x="8393502" y="1920240"/>
             <a:ext cx="3114136" cy="923330"/>
           </a:xfrm>
           <a:prstGeom prst="rect">
@@ -5337,15 +5064,380 @@
           <a:lstStyle/>
           <a:p>
             <a:r>
-              <a:rPr dirty="0"/>
               <a:t>Ridge vs Lasso</a:t>
             </a:r>
+          </a:p>
+        </p:txBody>
+      </p:sp>
+      <p:graphicFrame>
+        <p:nvGraphicFramePr>
+          <p:cNvPr id="302" name="Lasso vs Ridge comparison" descr="Table comparing Lasso and Ridge regression on coefficients, variable selection, correlated features, and when each performs best."/>
+          <p:cNvGraphicFramePr>
+            <a:graphicFrameLocks noGrp="1"/>
+          </p:cNvGraphicFramePr>
+          <p:nvPr>
+            <p:extLst>
+              <p:ext uri="{D42A27DB-BD31-4B8C-83A1-F6EECF244321}">
+                <p14:modId xmlns:p14="http://schemas.microsoft.com/office/powerpoint/2010/main" val="17385588"/>
+              </p:ext>
+            </p:extLst>
+          </p:nvPr>
+        </p:nvGraphicFramePr>
+        <p:xfrm>
+          <a:off x="927053" y="1738685"/>
+          <a:ext cx="10337894" cy="3100000"/>
+        </p:xfrm>
+        <a:graphic>
+          <a:graphicData uri="http://schemas.openxmlformats.org/drawingml/2006/table">
+            <a:tbl>
+              <a:tblPr firstRow="1" firstCol="1" bandRow="1">
+                <a:tableStyleId>{5C22544A-7EE6-4342-B048-85BDC9FD1C3A}</a:tableStyleId>
+              </a:tblPr>
+              <a:tblGrid>
+                <a:gridCol w="2600000">
+                  <a:extLst>
+                    <a:ext uri="{9D8B030D-6E8A-4147-A177-3AD203B41FA5}">
+                      <a16:colId xmlns:a16="http://schemas.microsoft.com/office/drawing/2014/main" val="20000"/>
+                    </a:ext>
+                  </a:extLst>
+                </a:gridCol>
+                <a:gridCol w="3868947">
+                  <a:extLst>
+                    <a:ext uri="{9D8B030D-6E8A-4147-A177-3AD203B41FA5}">
+                      <a16:colId xmlns:a16="http://schemas.microsoft.com/office/drawing/2014/main" val="20001"/>
+                    </a:ext>
+                  </a:extLst>
+                </a:gridCol>
+                <a:gridCol w="3868947">
+                  <a:extLst>
+                    <a:ext uri="{9D8B030D-6E8A-4147-A177-3AD203B41FA5}">
+                      <a16:colId xmlns:a16="http://schemas.microsoft.com/office/drawing/2014/main" val="20002"/>
+                    </a:ext>
+                  </a:extLst>
+                </a:gridCol>
+              </a:tblGrid>
+              <a:tr h="500000">
+                <a:tc>
+                  <a:txBody>
+                    <a:bodyPr/>
+                    <a:lstStyle/>
+                    <a:p>
+                      <a:r>
+                        <a:rPr lang="en-US" sz="1600" b="1"/>
+                        <a:t> </a:t>
+                      </a:r>
+                    </a:p>
+                  </a:txBody>
+                  <a:tcPr/>
+                </a:tc>
+                <a:tc>
+                  <a:txBody>
+                    <a:bodyPr/>
+                    <a:lstStyle/>
+                    <a:p>
+                      <a:r>
+                        <a:rPr lang="en-US" sz="1600" b="1"/>
+                        <a:t>Lasso (ℓ1)</a:t>
+                      </a:r>
+                    </a:p>
+                  </a:txBody>
+                  <a:tcPr/>
+                </a:tc>
+                <a:tc>
+                  <a:txBody>
+                    <a:bodyPr/>
+                    <a:lstStyle/>
+                    <a:p>
+                      <a:r>
+                        <a:rPr lang="en-US" sz="1600" b="1"/>
+                        <a:t>Ridge (ℓ2)</a:t>
+                      </a:r>
+                    </a:p>
+                  </a:txBody>
+                  <a:tcPr/>
+                </a:tc>
+                <a:extLst>
+                  <a:ext uri="{0D108BD9-81ED-4DB2-BD59-A6C34878D82A}">
+                    <a16:rowId xmlns:a16="http://schemas.microsoft.com/office/drawing/2014/main" val="10000"/>
+                  </a:ext>
+                </a:extLst>
+              </a:tr>
+              <a:tr h="620000">
+                <a:tc>
+                  <a:txBody>
+                    <a:bodyPr/>
+                    <a:lstStyle/>
+                    <a:p>
+                      <a:r>
+                        <a:rPr lang="en-US" sz="1500" b="1"/>
+                        <a:t>Coefficients</a:t>
+                      </a:r>
+                    </a:p>
+                  </a:txBody>
+                  <a:tcPr/>
+                </a:tc>
+                <a:tc>
+                  <a:txBody>
+                    <a:bodyPr/>
+                    <a:lstStyle/>
+                    <a:p>
+                      <a:r>
+                        <a:rPr lang="en-US" sz="1500"/>
+                        <a:t>Can be driven to exactly 0</a:t>
+                      </a:r>
+                    </a:p>
+                  </a:txBody>
+                  <a:tcPr/>
+                </a:tc>
+                <a:tc>
+                  <a:txBody>
+                    <a:bodyPr/>
+                    <a:lstStyle/>
+                    <a:p>
+                      <a:r>
+                        <a:rPr lang="en-US" sz="1500"/>
+                        <a:t>Shrink toward 0, never exactly 0</a:t>
+                      </a:r>
+                    </a:p>
+                  </a:txBody>
+                  <a:tcPr/>
+                </a:tc>
+                <a:extLst>
+                  <a:ext uri="{0D108BD9-81ED-4DB2-BD59-A6C34878D82A}">
+                    <a16:rowId xmlns:a16="http://schemas.microsoft.com/office/drawing/2014/main" val="10001"/>
+                  </a:ext>
+                </a:extLst>
+              </a:tr>
+              <a:tr h="620000">
+                <a:tc>
+                  <a:txBody>
+                    <a:bodyPr/>
+                    <a:lstStyle/>
+                    <a:p>
+                      <a:r>
+                        <a:rPr lang="en-US" sz="1500" b="1"/>
+                        <a:t>Variable selection</a:t>
+                      </a:r>
+                    </a:p>
+                  </a:txBody>
+                  <a:tcPr/>
+                </a:tc>
+                <a:tc>
+                  <a:txBody>
+                    <a:bodyPr/>
+                    <a:lstStyle/>
+                    <a:p>
+                      <a:r>
+                        <a:rPr lang="en-US" sz="1500"/>
+                        <a:t>Built in</a:t>
+                      </a:r>
+                    </a:p>
+                  </a:txBody>
+                  <a:tcPr/>
+                </a:tc>
+                <a:tc>
+                  <a:txBody>
+                    <a:bodyPr/>
+                    <a:lstStyle/>
+                    <a:p>
+                      <a:r>
+                        <a:rPr lang="en-US" sz="1500"/>
+                        <a:t>None — keeps every feature</a:t>
+                      </a:r>
+                    </a:p>
+                  </a:txBody>
+                  <a:tcPr/>
+                </a:tc>
+                <a:extLst>
+                  <a:ext uri="{0D108BD9-81ED-4DB2-BD59-A6C34878D82A}">
+                    <a16:rowId xmlns:a16="http://schemas.microsoft.com/office/drawing/2014/main" val="10002"/>
+                  </a:ext>
+                </a:extLst>
+              </a:tr>
+              <a:tr h="680000">
+                <a:tc>
+                  <a:txBody>
+                    <a:bodyPr/>
+                    <a:lstStyle/>
+                    <a:p>
+                      <a:r>
+                        <a:rPr lang="en-US" sz="1500" b="1" dirty="0"/>
+                        <a:t>Correlated features</a:t>
+                      </a:r>
+                    </a:p>
+                  </a:txBody>
+                  <a:tcPr/>
+                </a:tc>
+                <a:tc>
+                  <a:txBody>
+                    <a:bodyPr/>
+                    <a:lstStyle/>
+                    <a:p>
+                      <a:r>
+                        <a:rPr lang="en-US" sz="1500"/>
+                        <a:t>Picks one somewhat arbitrarily; estimates unstable</a:t>
+                      </a:r>
+                    </a:p>
+                  </a:txBody>
+                  <a:tcPr/>
+                </a:tc>
+                <a:tc>
+                  <a:txBody>
+                    <a:bodyPr/>
+                    <a:lstStyle/>
+                    <a:p>
+                      <a:r>
+                        <a:rPr lang="en-US" sz="1500"/>
+                        <a:t>Spreads weight across them; estimates stable</a:t>
+                      </a:r>
+                    </a:p>
+                  </a:txBody>
+                  <a:tcPr/>
+                </a:tc>
+                <a:extLst>
+                  <a:ext uri="{0D108BD9-81ED-4DB2-BD59-A6C34878D82A}">
+                    <a16:rowId xmlns:a16="http://schemas.microsoft.com/office/drawing/2014/main" val="10003"/>
+                  </a:ext>
+                </a:extLst>
+              </a:tr>
+              <a:tr h="680000">
+                <a:tc>
+                  <a:txBody>
+                    <a:bodyPr/>
+                    <a:lstStyle/>
+                    <a:p>
+                      <a:r>
+                        <a:rPr lang="en-US" sz="1500" b="1"/>
+                        <a:t>Performs best when</a:t>
+                      </a:r>
+                    </a:p>
+                  </a:txBody>
+                  <a:tcPr/>
+                </a:tc>
+                <a:tc>
+                  <a:txBody>
+                    <a:bodyPr/>
+                    <a:lstStyle/>
+                    <a:p>
+                      <a:r>
+                        <a:rPr lang="en-US" sz="1500"/>
+                        <a:t>Many features contribute little to prediction</a:t>
+                      </a:r>
+                    </a:p>
+                  </a:txBody>
+                  <a:tcPr/>
+                </a:tc>
+                <a:tc>
+                  <a:txBody>
+                    <a:bodyPr/>
+                    <a:lstStyle/>
+                    <a:p>
+                      <a:r>
+                        <a:rPr lang="en-US" sz="1500" dirty="0"/>
+                        <a:t>Many features contribute, and are correlated</a:t>
+                      </a:r>
+                    </a:p>
+                  </a:txBody>
+                  <a:tcPr/>
+                </a:tc>
+                <a:extLst>
+                  <a:ext uri="{0D108BD9-81ED-4DB2-BD59-A6C34878D82A}">
+                    <a16:rowId xmlns:a16="http://schemas.microsoft.com/office/drawing/2014/main" val="10004"/>
+                  </a:ext>
+                </a:extLst>
+              </a:tr>
+            </a:tbl>
+          </a:graphicData>
+        </a:graphic>
+      </p:graphicFrame>
+      <p:sp>
+        <p:nvSpPr>
+          <p:cNvPr id="320" name="Takeaway note"/>
+          <p:cNvSpPr txBox="1"/>
+          <p:nvPr/>
+        </p:nvSpPr>
+        <p:spPr>
+          <a:xfrm>
+            <a:off x="927053" y="5500000"/>
+            <a:ext cx="10337894" cy="600000"/>
+          </a:xfrm>
+          <a:prstGeom prst="rect">
+            <a:avLst/>
+          </a:prstGeom>
+        </p:spPr>
+        <p:txBody>
+          <a:bodyPr wrap="square">
+            <a:normAutofit/>
+          </a:bodyPr>
+          <a:lstStyle/>
+          <a:p>
+            <a:r>
+              <a:rPr lang="en-US" sz="1600" b="1"/>
+              <a:t>Neither method universally dominates </a:t>
+            </a:r>
+            <a:r>
+              <a:rPr lang="en-US" sz="1600"/>
+              <a:t>— the right choice depends on how many features actually matter.</a:t>
+            </a:r>
+          </a:p>
+        </p:txBody>
+      </p:sp>
+    </p:spTree>
+  </p:cSld>
+  <p:clrMapOvr>
+    <a:masterClrMapping/>
+  </p:clrMapOvr>
+  <p:transition spd="med"/>
+</p:sld>
+</file>
+
+<file path=ppt/slides/slide12.xml><?xml version="1.0" encoding="utf-8"?>
+<p:sld xmlns:a="http://schemas.openxmlformats.org/drawingml/2006/main" xmlns:r="http://schemas.openxmlformats.org/officeDocument/2006/relationships" xmlns:p="http://schemas.openxmlformats.org/presentationml/2006/main">
+  <p:cSld>
+    <p:spTree>
+      <p:nvGrpSpPr>
+        <p:cNvPr id="1" name=""/>
+        <p:cNvGrpSpPr/>
+        <p:nvPr/>
+      </p:nvGrpSpPr>
+      <p:grpSpPr>
+        <a:xfrm>
+          <a:off x="0" y="0"/>
+          <a:ext cx="0" cy="0"/>
+          <a:chOff x="0" y="0"/>
+          <a:chExt cx="0" cy="0"/>
+        </a:xfrm>
+      </p:grpSpPr>
+      <p:sp>
+        <p:nvSpPr>
+          <p:cNvPr id="314" name="Regularization"/>
+          <p:cNvSpPr txBox="1">
+            <a:spLocks noGrp="1"/>
+          </p:cNvSpPr>
+          <p:nvPr>
+            <p:ph type="title"/>
+          </p:nvPr>
+        </p:nvSpPr>
+        <p:spPr>
+          <a:prstGeom prst="rect">
+            <a:avLst/>
+          </a:prstGeom>
+        </p:spPr>
+        <p:txBody>
+          <a:bodyPr/>
+          <a:lstStyle/>
+          <a:p>
+            <a:r>
+              <a:rPr lang="en-US"/>
+              <a:t>Choosing the Tuning Parameter</a:t>
+            </a:r>
+            <a:endParaRPr dirty="0"/>
           </a:p>
         </p:txBody>
       </p:sp>
       <p:sp>
         <p:nvSpPr>
-          <p:cNvPr id="302" name="Lasso…"/>
+          <p:cNvPr id="315" name="We’ve just looked at Lasso, Ridge, and Elastic net (explicit regularization) in the context of linear regression…"/>
           <p:cNvSpPr txBox="1">
             <a:spLocks noGrp="1"/>
           </p:cNvSpPr>
@@ -5354,87 +5446,135 @@
           </p:nvPr>
         </p:nvSpPr>
         <p:spPr>
-          <a:xfrm>
-            <a:off x="927053" y="1738685"/>
-            <a:ext cx="10337894" cy="4817963"/>
-          </a:xfrm>
           <a:prstGeom prst="rect">
             <a:avLst/>
           </a:prstGeom>
         </p:spPr>
         <p:txBody>
-          <a:bodyPr>
-            <a:normAutofit/>
-          </a:bodyPr>
+          <a:bodyPr/>
           <a:lstStyle/>
           <a:p>
             <a:r>
-              <a:rPr sz="1800" dirty="0"/>
-              <a:t>Lasso</a:t>
-            </a:r>
-          </a:p>
-          <a:p>
-            <a:pPr lvl="1"/>
-            <a:r>
-              <a:rPr dirty="0"/>
-              <a:t>Forces some coefficients to be exactly 0  (advantage)</a:t>
-            </a:r>
-          </a:p>
-          <a:p>
-            <a:pPr lvl="1"/>
-            <a:r>
-              <a:rPr dirty="0"/>
-              <a:t>Built in variable selection</a:t>
-            </a:r>
-          </a:p>
-          <a:p>
-            <a:pPr lvl="1"/>
-            <a:r>
-              <a:rPr dirty="0"/>
-              <a:t>Coefficients can be very different for correlated features (disadvantage)</a:t>
-            </a:r>
-          </a:p>
-          <a:p>
-            <a:r>
-              <a:rPr sz="1800" dirty="0"/>
-              <a:t>Ridge </a:t>
-            </a:r>
-          </a:p>
-          <a:p>
-            <a:pPr lvl="1"/>
-            <a:r>
-              <a:rPr dirty="0"/>
-              <a:t>Coefficients will never be exactly 0 (fact)</a:t>
-            </a:r>
-          </a:p>
-          <a:p>
-            <a:pPr lvl="1"/>
-            <a:r>
-              <a:rPr dirty="0"/>
-              <a:t>Tends to estimate similar coefficient for correlated features (advantage)</a:t>
+              <a:rPr lang="el-GR"/>
+              <a:t>α </a:t>
+            </a:r>
+            <a:r>
+              <a:rPr lang="en-US"/>
+              <a:t>controls the bias–variance tradeoff</a:t>
+            </a:r>
+          </a:p>
+          <a:p>
+            <a:r>
+              <a:rPr lang="el-GR"/>
+              <a:t>α → 0: </a:t>
+            </a:r>
+            <a:r>
+              <a:rPr lang="en-US"/>
+              <a:t>back to ordinary least squares (low bias, high variance)</a:t>
+            </a:r>
+          </a:p>
+          <a:p>
+            <a:r>
+              <a:rPr lang="el-GR"/>
+              <a:t>α → ∞: </a:t>
+            </a:r>
+            <a:r>
+              <a:rPr lang="en-US"/>
+              <a:t>all coefficients shrink toward 0 (high bias, low variance)</a:t>
+            </a:r>
+          </a:p>
+          <a:p>
+            <a:r>
+              <a:rPr lang="en-US"/>
+              <a:t>Choose </a:t>
+            </a:r>
+            <a:r>
+              <a:rPr lang="el-GR"/>
+              <a:t>α </a:t>
+            </a:r>
+            <a:r>
+              <a:rPr lang="en-US"/>
+              <a:t>by k-fold cross-validation: fit over </a:t>
+            </a:r>
+            <a:r>
+              <a:rPr lang="en-US" dirty="0"/>
+              <a:t>a </a:t>
+            </a:r>
+            <a:r>
+              <a:rPr lang="en-US"/>
+              <a:t>grid </a:t>
+            </a:r>
+            <a:r>
+              <a:rPr lang="en-US" dirty="0"/>
+              <a:t>of </a:t>
+            </a:r>
+            <a:r>
+              <a:rPr lang="el-GR"/>
+              <a:t>α </a:t>
+            </a:r>
+            <a:r>
+              <a:rPr lang="en-US"/>
+              <a:t>values</a:t>
+            </a:r>
+            <a:r>
+              <a:rPr lang="en-US" dirty="0"/>
+              <a:t>, </a:t>
+            </a:r>
+            <a:r>
+              <a:rPr lang="en-US"/>
+              <a:t>pick the one minimizing CV error</a:t>
             </a:r>
             <a:endParaRPr lang="en-US" dirty="0"/>
           </a:p>
           <a:p>
             <a:r>
-              <a:rPr lang="en-US" sz="1800" dirty="0"/>
-              <a:t>Neither method will universally dominate </a:t>
-            </a:r>
-          </a:p>
-          <a:p>
-            <a:r>
-              <a:rPr lang="en-US" sz="1800" dirty="0"/>
-              <a:t>Lasso generally performs better when many of the features don’t contribute to predictability </a:t>
-            </a:r>
-          </a:p>
-          <a:p>
-            <a:r>
-              <a:rPr lang="en-US" sz="1800" dirty="0"/>
-              <a:t>Ridge generally performs better when many of the features contribute to the prediction and when features are correlated </a:t>
-            </a:r>
-          </a:p>
-          <a:p>
-            <a:endParaRPr lang="en-US" sz="1800" dirty="0"/>
+              <a:rPr lang="en-US"/>
+              <a:t>The regularization path plots coefficients against </a:t>
+            </a:r>
+            <a:r>
+              <a:rPr lang="el-GR"/>
+              <a:t>α — </a:t>
+            </a:r>
+            <a:r>
+              <a:rPr lang="en-US"/>
+              <a:t>useful for seeing which features survive</a:t>
+            </a:r>
+          </a:p>
+          <a:p>
+            <a:r>
+              <a:rPr lang="en-US"/>
+              <a:t>Always standardize predictors first</a:t>
+            </a:r>
+            <a:r>
+              <a:rPr lang="en-US" dirty="0"/>
+              <a:t>: </a:t>
+            </a:r>
+            <a:r>
+              <a:rPr lang="en-US"/>
+              <a:t>penalties are not scale-invariant</a:t>
+            </a:r>
+            <a:r>
+              <a:rPr lang="en-US" dirty="0"/>
+              <a:t>, </a:t>
+            </a:r>
+            <a:r>
+              <a:rPr lang="en-US"/>
+              <a:t>so units change </a:t>
+            </a:r>
+            <a:r>
+              <a:rPr lang="en-US" dirty="0"/>
+              <a:t>the </a:t>
+            </a:r>
+            <a:r>
+              <a:rPr lang="en-US"/>
+              <a:t>answer</a:t>
+            </a:r>
+          </a:p>
+          <a:p>
+            <a:r>
+              <a:rPr lang="en-US"/>
+              <a:t>The intercept β₀ is not penalized</a:t>
+            </a:r>
           </a:p>
         </p:txBody>
       </p:sp>
@@ -5444,298 +5584,10 @@
     <a:masterClrMapping/>
   </p:clrMapOvr>
   <p:transition spd="med"/>
-  <p:timing>
-    <p:tnLst>
-      <p:par>
-        <p:cTn id="1" dur="indefinite" restart="never" nodeType="tmRoot">
-          <p:childTnLst>
-            <p:seq concurrent="1" nextAc="seek">
-              <p:cTn id="2" dur="indefinite" nodeType="mainSeq">
-                <p:childTnLst>
-                  <p:par>
-                    <p:cTn id="3" fill="hold">
-                      <p:stCondLst>
-                        <p:cond delay="indefinite"/>
-                      </p:stCondLst>
-                      <p:childTnLst>
-                        <p:par>
-                          <p:cTn id="4" fill="hold">
-                            <p:stCondLst>
-                              <p:cond delay="0"/>
-                            </p:stCondLst>
-                            <p:childTnLst>
-                              <p:par>
-                                <p:cTn id="5" presetID="1" presetClass="entr" presetSubtype="0" fill="hold" nodeType="clickEffect">
-                                  <p:stCondLst>
-                                    <p:cond delay="0"/>
-                                  </p:stCondLst>
-                                  <p:childTnLst>
-                                    <p:set>
-                                      <p:cBhvr>
-                                        <p:cTn id="6" dur="1" fill="hold">
-                                          <p:stCondLst>
-                                            <p:cond delay="0"/>
-                                          </p:stCondLst>
-                                        </p:cTn>
-                                        <p:tgtEl>
-                                          <p:spTgt spid="302">
-                                            <p:txEl>
-                                              <p:pRg st="4" end="4"/>
-                                            </p:txEl>
-                                          </p:spTgt>
-                                        </p:tgtEl>
-                                        <p:attrNameLst>
-                                          <p:attrName>style.visibility</p:attrName>
-                                        </p:attrNameLst>
-                                      </p:cBhvr>
-                                      <p:to>
-                                        <p:strVal val="visible"/>
-                                      </p:to>
-                                    </p:set>
-                                  </p:childTnLst>
-                                </p:cTn>
-                              </p:par>
-                              <p:par>
-                                <p:cTn id="7" presetID="1" presetClass="entr" presetSubtype="0" fill="hold" nodeType="withEffect">
-                                  <p:stCondLst>
-                                    <p:cond delay="0"/>
-                                  </p:stCondLst>
-                                  <p:childTnLst>
-                                    <p:set>
-                                      <p:cBhvr>
-                                        <p:cTn id="8" dur="1" fill="hold">
-                                          <p:stCondLst>
-                                            <p:cond delay="0"/>
-                                          </p:stCondLst>
-                                        </p:cTn>
-                                        <p:tgtEl>
-                                          <p:spTgt spid="302">
-                                            <p:txEl>
-                                              <p:pRg st="5" end="5"/>
-                                            </p:txEl>
-                                          </p:spTgt>
-                                        </p:tgtEl>
-                                        <p:attrNameLst>
-                                          <p:attrName>style.visibility</p:attrName>
-                                        </p:attrNameLst>
-                                      </p:cBhvr>
-                                      <p:to>
-                                        <p:strVal val="visible"/>
-                                      </p:to>
-                                    </p:set>
-                                  </p:childTnLst>
-                                </p:cTn>
-                              </p:par>
-                              <p:par>
-                                <p:cTn id="9" presetID="1" presetClass="entr" presetSubtype="0" fill="hold" nodeType="withEffect">
-                                  <p:stCondLst>
-                                    <p:cond delay="0"/>
-                                  </p:stCondLst>
-                                  <p:childTnLst>
-                                    <p:set>
-                                      <p:cBhvr>
-                                        <p:cTn id="10" dur="1" fill="hold">
-                                          <p:stCondLst>
-                                            <p:cond delay="0"/>
-                                          </p:stCondLst>
-                                        </p:cTn>
-                                        <p:tgtEl>
-                                          <p:spTgt spid="302">
-                                            <p:txEl>
-                                              <p:pRg st="6" end="6"/>
-                                            </p:txEl>
-                                          </p:spTgt>
-                                        </p:tgtEl>
-                                        <p:attrNameLst>
-                                          <p:attrName>style.visibility</p:attrName>
-                                        </p:attrNameLst>
-                                      </p:cBhvr>
-                                      <p:to>
-                                        <p:strVal val="visible"/>
-                                      </p:to>
-                                    </p:set>
-                                  </p:childTnLst>
-                                </p:cTn>
-                              </p:par>
-                            </p:childTnLst>
-                          </p:cTn>
-                        </p:par>
-                      </p:childTnLst>
-                    </p:cTn>
-                  </p:par>
-                  <p:par>
-                    <p:cTn id="11" fill="hold">
-                      <p:stCondLst>
-                        <p:cond delay="indefinite"/>
-                      </p:stCondLst>
-                      <p:childTnLst>
-                        <p:par>
-                          <p:cTn id="12" fill="hold">
-                            <p:stCondLst>
-                              <p:cond delay="0"/>
-                            </p:stCondLst>
-                            <p:childTnLst>
-                              <p:par>
-                                <p:cTn id="13" presetID="1" presetClass="entr" presetSubtype="0" fill="hold" nodeType="clickEffect">
-                                  <p:stCondLst>
-                                    <p:cond delay="0"/>
-                                  </p:stCondLst>
-                                  <p:childTnLst>
-                                    <p:set>
-                                      <p:cBhvr>
-                                        <p:cTn id="14" dur="1" fill="hold">
-                                          <p:stCondLst>
-                                            <p:cond delay="0"/>
-                                          </p:stCondLst>
-                                        </p:cTn>
-                                        <p:tgtEl>
-                                          <p:spTgt spid="302">
-                                            <p:txEl>
-                                              <p:pRg st="7" end="7"/>
-                                            </p:txEl>
-                                          </p:spTgt>
-                                        </p:tgtEl>
-                                        <p:attrNameLst>
-                                          <p:attrName>style.visibility</p:attrName>
-                                        </p:attrNameLst>
-                                      </p:cBhvr>
-                                      <p:to>
-                                        <p:strVal val="visible"/>
-                                      </p:to>
-                                    </p:set>
-                                  </p:childTnLst>
-                                </p:cTn>
-                              </p:par>
-                            </p:childTnLst>
-                          </p:cTn>
-                        </p:par>
-                      </p:childTnLst>
-                    </p:cTn>
-                  </p:par>
-                  <p:par>
-                    <p:cTn id="15" fill="hold">
-                      <p:stCondLst>
-                        <p:cond delay="indefinite"/>
-                      </p:stCondLst>
-                      <p:childTnLst>
-                        <p:par>
-                          <p:cTn id="16" fill="hold">
-                            <p:stCondLst>
-                              <p:cond delay="0"/>
-                            </p:stCondLst>
-                            <p:childTnLst>
-                              <p:par>
-                                <p:cTn id="17" presetID="1" presetClass="entr" presetSubtype="0" fill="hold" nodeType="clickEffect">
-                                  <p:stCondLst>
-                                    <p:cond delay="0"/>
-                                  </p:stCondLst>
-                                  <p:childTnLst>
-                                    <p:set>
-                                      <p:cBhvr>
-                                        <p:cTn id="18" dur="1" fill="hold">
-                                          <p:stCondLst>
-                                            <p:cond delay="0"/>
-                                          </p:stCondLst>
-                                        </p:cTn>
-                                        <p:tgtEl>
-                                          <p:spTgt spid="302">
-                                            <p:txEl>
-                                              <p:pRg st="8" end="8"/>
-                                            </p:txEl>
-                                          </p:spTgt>
-                                        </p:tgtEl>
-                                        <p:attrNameLst>
-                                          <p:attrName>style.visibility</p:attrName>
-                                        </p:attrNameLst>
-                                      </p:cBhvr>
-                                      <p:to>
-                                        <p:strVal val="visible"/>
-                                      </p:to>
-                                    </p:set>
-                                  </p:childTnLst>
-                                </p:cTn>
-                              </p:par>
-                            </p:childTnLst>
-                          </p:cTn>
-                        </p:par>
-                      </p:childTnLst>
-                    </p:cTn>
-                  </p:par>
-                  <p:par>
-                    <p:cTn id="19" fill="hold">
-                      <p:stCondLst>
-                        <p:cond delay="indefinite"/>
-                      </p:stCondLst>
-                      <p:childTnLst>
-                        <p:par>
-                          <p:cTn id="20" fill="hold">
-                            <p:stCondLst>
-                              <p:cond delay="0"/>
-                            </p:stCondLst>
-                            <p:childTnLst>
-                              <p:par>
-                                <p:cTn id="21" presetID="1" presetClass="entr" presetSubtype="0" fill="hold" nodeType="clickEffect">
-                                  <p:stCondLst>
-                                    <p:cond delay="0"/>
-                                  </p:stCondLst>
-                                  <p:childTnLst>
-                                    <p:set>
-                                      <p:cBhvr>
-                                        <p:cTn id="22" dur="1" fill="hold">
-                                          <p:stCondLst>
-                                            <p:cond delay="0"/>
-                                          </p:stCondLst>
-                                        </p:cTn>
-                                        <p:tgtEl>
-                                          <p:spTgt spid="302">
-                                            <p:txEl>
-                                              <p:pRg st="9" end="9"/>
-                                            </p:txEl>
-                                          </p:spTgt>
-                                        </p:tgtEl>
-                                        <p:attrNameLst>
-                                          <p:attrName>style.visibility</p:attrName>
-                                        </p:attrNameLst>
-                                      </p:cBhvr>
-                                      <p:to>
-                                        <p:strVal val="visible"/>
-                                      </p:to>
-                                    </p:set>
-                                  </p:childTnLst>
-                                </p:cTn>
-                              </p:par>
-                            </p:childTnLst>
-                          </p:cTn>
-                        </p:par>
-                      </p:childTnLst>
-                    </p:cTn>
-                  </p:par>
-                </p:childTnLst>
-              </p:cTn>
-              <p:prevCondLst>
-                <p:cond evt="onPrev" delay="0">
-                  <p:tgtEl>
-                    <p:sldTgt/>
-                  </p:tgtEl>
-                </p:cond>
-              </p:prevCondLst>
-              <p:nextCondLst>
-                <p:cond evt="onNext" delay="0">
-                  <p:tgtEl>
-                    <p:sldTgt/>
-                  </p:tgtEl>
-                </p:cond>
-              </p:nextCondLst>
-            </p:seq>
-          </p:childTnLst>
-        </p:cTn>
-      </p:par>
-    </p:tnLst>
-  </p:timing>
 </p:sld>
 </file>
 
-<file path=ppt/slides/slide12.xml><?xml version="1.0" encoding="utf-8"?>
+<file path=ppt/slides/slide13.xml><?xml version="1.0" encoding="utf-8"?>
 <p:sld xmlns:a="http://schemas.openxmlformats.org/drawingml/2006/main" xmlns:r="http://schemas.openxmlformats.org/officeDocument/2006/relationships" xmlns:p="http://schemas.openxmlformats.org/presentationml/2006/main">
   <p:cSld>
     <p:spTree>
@@ -6994,7 +6846,7 @@
 </p:sld>
 </file>
 
-<file path=ppt/slides/slide13.xml><?xml version="1.0" encoding="utf-8"?>
+<file path=ppt/slides/slide14.xml><?xml version="1.0" encoding="utf-8"?>
 <p:sld xmlns:a="http://schemas.openxmlformats.org/drawingml/2006/main" xmlns:r="http://schemas.openxmlformats.org/officeDocument/2006/relationships" xmlns:p="http://schemas.openxmlformats.org/presentationml/2006/main">
   <p:cSld>
     <p:spTree>
@@ -7031,15 +6883,159 @@
           <a:lstStyle/>
           <a:p>
             <a:r>
-              <a:rPr dirty="0"/>
+              <a:rPr lang="en-US"/>
+              <a:t>In Practice: Fitting Regularized Models</a:t>
+            </a:r>
+            <a:endParaRPr/>
+          </a:p>
+        </p:txBody>
+      </p:sp>
+      <p:sp>
+        <p:nvSpPr>
+          <p:cNvPr id="315" name="We’ve just looked at Lasso, Ridge, and Elastic net (explicit regularization) in the context of linear regression…"/>
+          <p:cNvSpPr txBox="1">
+            <a:spLocks noGrp="1"/>
+          </p:cNvSpPr>
+          <p:nvPr>
+            <p:ph type="body" idx="1"/>
+          </p:nvPr>
+        </p:nvSpPr>
+        <p:spPr>
+          <a:prstGeom prst="rect">
+            <a:avLst/>
+          </a:prstGeom>
+        </p:spPr>
+        <p:txBody>
+          <a:bodyPr>
+            <a:normAutofit/>
+          </a:bodyPr>
+          <a:lstStyle/>
+          <a:p>
+            <a:r>
+              <a:rPr lang="en-US" sz="1800" dirty="0"/>
+              <a:t>Python — scikit-learn</a:t>
+            </a:r>
+          </a:p>
+          <a:p>
+            <a:r>
+              <a:rPr lang="en-US" dirty="0" err="1"/>
+              <a:t>make_pipeline</a:t>
+            </a:r>
+            <a:r>
+              <a:rPr lang="en-US" dirty="0"/>
+              <a:t>(</a:t>
+            </a:r>
+            <a:r>
+              <a:rPr lang="en-US" dirty="0" err="1"/>
+              <a:t>StandardScaler</a:t>
+            </a:r>
+            <a:r>
+              <a:rPr lang="en-US" dirty="0"/>
+              <a:t>(), </a:t>
+            </a:r>
+            <a:r>
+              <a:rPr lang="en-US" dirty="0" err="1"/>
+              <a:t>LassoCV</a:t>
+            </a:r>
+            <a:r>
+              <a:rPr lang="en-US" dirty="0"/>
+              <a:t>(cv=10)).fit(X, y)</a:t>
+            </a:r>
+          </a:p>
+          <a:p>
+            <a:r>
+              <a:rPr lang="en-US" sz="1800" dirty="0"/>
+              <a:t>R — </a:t>
+            </a:r>
+            <a:r>
+              <a:rPr lang="en-US" sz="1800" dirty="0" err="1"/>
+              <a:t>glmnet</a:t>
+            </a:r>
+            <a:endParaRPr lang="en-US" sz="1800" dirty="0"/>
+          </a:p>
+          <a:p>
+            <a:r>
+              <a:rPr lang="en-US" dirty="0" err="1"/>
+              <a:t>cv.glmnet</a:t>
+            </a:r>
+            <a:r>
+              <a:rPr lang="en-US" dirty="0"/>
+              <a:t>(X, y, alpha = 1)</a:t>
+            </a:r>
+          </a:p>
+          <a:p>
+            <a:r>
+              <a:rPr lang="en-US" sz="1800" dirty="0"/>
+              <a:t>alpha: 1 = Lasso, 0 = Ridge, between = Elastic Net</a:t>
+            </a:r>
+          </a:p>
+          <a:p>
+            <a:r>
+              <a:rPr lang="en-US" sz="1800" dirty="0"/>
+              <a:t>Penalty-weight conventions differ between packages</a:t>
+            </a:r>
+            <a:endParaRPr dirty="0"/>
+          </a:p>
+        </p:txBody>
+      </p:sp>
+    </p:spTree>
+    <p:extLst>
+      <p:ext uri="{BB962C8B-B14F-4D97-AF65-F5344CB8AC3E}">
+        <p14:creationId xmlns:p14="http://schemas.microsoft.com/office/powerpoint/2010/main" val="450852903"/>
+      </p:ext>
+    </p:extLst>
+  </p:cSld>
+  <p:clrMapOvr>
+    <a:masterClrMapping/>
+  </p:clrMapOvr>
+  <p:transition spd="med"/>
+</p:sld>
+</file>
+
+<file path=ppt/slides/slide15.xml><?xml version="1.0" encoding="utf-8"?>
+<p:sld xmlns:a="http://schemas.openxmlformats.org/drawingml/2006/main" xmlns:r="http://schemas.openxmlformats.org/officeDocument/2006/relationships" xmlns:p="http://schemas.openxmlformats.org/presentationml/2006/main">
+  <p:cSld>
+    <p:spTree>
+      <p:nvGrpSpPr>
+        <p:cNvPr id="1" name=""/>
+        <p:cNvGrpSpPr/>
+        <p:nvPr/>
+      </p:nvGrpSpPr>
+      <p:grpSpPr>
+        <a:xfrm>
+          <a:off x="0" y="0"/>
+          <a:ext cx="0" cy="0"/>
+          <a:chOff x="0" y="0"/>
+          <a:chExt cx="0" cy="0"/>
+        </a:xfrm>
+      </p:grpSpPr>
+      <p:sp>
+        <p:nvSpPr>
+          <p:cNvPr id="314" name="Regularization"/>
+          <p:cNvSpPr txBox="1">
+            <a:spLocks noGrp="1"/>
+          </p:cNvSpPr>
+          <p:nvPr>
+            <p:ph type="title"/>
+          </p:nvPr>
+        </p:nvSpPr>
+        <p:spPr>
+          <a:prstGeom prst="rect">
+            <a:avLst/>
+          </a:prstGeom>
+        </p:spPr>
+        <p:txBody>
+          <a:bodyPr/>
+          <a:lstStyle/>
+          <a:p>
+            <a:r>
               <a:t>Regularization</a:t>
             </a:r>
             <a:r>
-              <a:rPr lang="en-US" dirty="0"/>
+              <a:rPr lang="en-US"/>
               <a:t> Generally</a:t>
             </a:r>
             <a:r>
-              <a:rPr dirty="0"/>
               <a:t> </a:t>
             </a:r>
           </a:p>
@@ -7065,41 +7061,37 @@
           <a:lstStyle/>
           <a:p>
             <a:r>
-              <a:rPr dirty="0"/>
-              <a:t>We’ve just looked at Lasso, Ridge, and Elastic net (explicit regularization) in the context of linear regression</a:t>
-            </a:r>
-          </a:p>
-          <a:p>
-            <a:r>
-              <a:rPr lang="en-US" dirty="0"/>
-              <a:t>Regularization is a general set of methodologies, not limited to linear regression</a:t>
-            </a:r>
-          </a:p>
-          <a:p>
-            <a:pPr lvl="1"/>
-            <a:r>
-              <a:rPr lang="en-US" dirty="0"/>
-              <a:t>Used in many models: logistic regression, neural networks, decision trees, etc.</a:t>
-            </a:r>
-          </a:p>
-          <a:p>
-            <a:pPr lvl="1"/>
-            <a:r>
-              <a:rPr lang="en-US" dirty="0"/>
-              <a:t>Goal: improve generalization by reducing overfitting</a:t>
-            </a:r>
-          </a:p>
-          <a:p>
-            <a:pPr lvl="1"/>
-            <a:r>
-              <a:rPr lang="en-US" dirty="0"/>
-              <a:t>Can be applied to weights, complexity, or even the training process</a:t>
-            </a:r>
-            <a:endParaRPr dirty="0"/>
+              <a:rPr lang="en-US"/>
+              <a:t>Regularization is a general idea, not a linear-regression trick</a:t>
+            </a:r>
+          </a:p>
+          <a:p>
+            <a:r>
+              <a:rPr lang="en-US"/>
+              <a:t>Used in logistic regression, neural networks, decision trees, and more</a:t>
+            </a:r>
+          </a:p>
+          <a:p>
+            <a:r>
+              <a:rPr lang="en-US"/>
+              <a:t>Implicit forms need no penalty term: early stopping, dropout, pruning</a:t>
+            </a:r>
+          </a:p>
+          <a:p>
+            <a:r>
+              <a:rPr lang="en-US"/>
+              <a:t>Applies to weights, complexity, or the training process itself</a:t>
+            </a:r>
+            <a:endParaRPr/>
           </a:p>
         </p:txBody>
       </p:sp>
     </p:spTree>
+    <p:extLst>
+      <p:ext uri="{BB962C8B-B14F-4D97-AF65-F5344CB8AC3E}">
+        <p14:creationId xmlns:p14="http://schemas.microsoft.com/office/powerpoint/2010/main" val="178340659"/>
+      </p:ext>
+    </p:extLst>
   </p:cSld>
   <p:clrMapOvr>
     <a:masterClrMapping/>
@@ -7108,7 +7100,7 @@
 </p:sld>
 </file>
 
-<file path=ppt/slides/slide2.xml><?xml version="1.0" encoding="utf-8"?>
+<file path=ppt/slides/slide16.xml><?xml version="1.0" encoding="utf-8"?>
 <p:sld xmlns:a="http://schemas.openxmlformats.org/drawingml/2006/main" xmlns:r="http://schemas.openxmlformats.org/officeDocument/2006/relationships" xmlns:p="http://schemas.openxmlformats.org/presentationml/2006/main">
   <p:cSld>
     <p:spTree>
@@ -7127,7 +7119,7 @@
       </p:grpSpPr>
       <p:sp>
         <p:nvSpPr>
-          <p:cNvPr id="240" name="Regularization"/>
+          <p:cNvPr id="314" name="Regularization"/>
           <p:cNvSpPr txBox="1">
             <a:spLocks noGrp="1"/>
           </p:cNvSpPr>
@@ -7145,14 +7137,16 @@
           <a:lstStyle/>
           <a:p>
             <a:r>
-              <a:t>Regularization</a:t>
-            </a:r>
+              <a:rPr lang="en-US"/>
+              <a:t>Regularized Models in scikit-learn</a:t>
+            </a:r>
+            <a:endParaRPr/>
           </a:p>
         </p:txBody>
       </p:sp>
       <p:sp>
         <p:nvSpPr>
-          <p:cNvPr id="241" name="We said that adding constraints to model is a way to simplify the model to help prevent overfitting…"/>
+          <p:cNvPr id="315" name="We’ve just looked at Lasso, Ridge, and Elastic net (explicit regularization) in the context of linear regression…"/>
           <p:cNvSpPr txBox="1">
             <a:spLocks noGrp="1"/>
           </p:cNvSpPr>
@@ -7171,201 +7165,176 @@
           <a:p>
             <a:r>
               <a:rPr lang="en-US" dirty="0"/>
-              <a:t>Adding </a:t>
-            </a:r>
-            <a:r>
-              <a:rPr dirty="0"/>
-              <a:t>constraints to model</a:t>
-            </a:r>
+              <a:t>By default: LogisticRegression, SVC</a:t>
+            </a:r>
+            <a:r>
+              <a:rPr lang="en-US"/>
+              <a:t>, MLP</a:t>
+            </a:r>
+            <a:endParaRPr lang="en-US" dirty="0"/>
+          </a:p>
+          <a:p>
             <a:r>
               <a:rPr lang="en-US" dirty="0"/>
-              <a:t> </a:t>
-            </a:r>
-            <a:r>
-              <a:rPr dirty="0"/>
-              <a:t>to </a:t>
-            </a:r>
+              <a:t>By design: Ridge, Lasso, </a:t>
+            </a:r>
+            <a:r>
+              <a:rPr lang="en-US" dirty="0" err="1"/>
+              <a:t>ElasticNet</a:t>
+            </a:r>
+            <a:endParaRPr lang="en-US" dirty="0"/>
+          </a:p>
+          <a:p>
             <a:r>
               <a:rPr lang="en-US" dirty="0"/>
-              <a:t>"</a:t>
-            </a:r>
-            <a:r>
-              <a:rPr dirty="0"/>
-              <a:t>simplify</a:t>
-            </a:r>
+              <a:t>By complexity: tree pruning, boosting, early stopping</a:t>
+            </a:r>
+          </a:p>
+          <a:p>
             <a:r>
               <a:rPr lang="en-US" dirty="0"/>
-              <a:t>"</a:t>
-            </a:r>
-            <a:r>
-              <a:rPr dirty="0"/>
-              <a:t> the model to help prevent overfitting</a:t>
-            </a:r>
-          </a:p>
-          <a:p>
-            <a:r>
-              <a:rPr lang="en-US" b="1" dirty="0"/>
-              <a:t>Regularization</a:t>
-            </a:r>
-            <a:r>
-              <a:rPr lang="en-US" dirty="0"/>
-              <a:t>: Techniques that constrain a model to reduce overfitting and improve generalization.</a:t>
-            </a:r>
-          </a:p>
-          <a:p>
-            <a:pPr lvl="1"/>
-            <a:r>
-              <a:rPr dirty="0"/>
-              <a:t>Explicit Regularization</a:t>
-            </a:r>
-          </a:p>
-          <a:p>
-            <a:pPr lvl="1"/>
-            <a:r>
-              <a:rPr dirty="0"/>
-              <a:t>Implicit Regularization </a:t>
-            </a:r>
+              <a:t>No penalty: </a:t>
+            </a:r>
+            <a:r>
+              <a:rPr lang="en-US" dirty="0" err="1"/>
+              <a:t>LinearRegression</a:t>
+            </a:r>
+            <a:endParaRPr dirty="0"/>
           </a:p>
         </p:txBody>
       </p:sp>
     </p:spTree>
+    <p:extLst>
+      <p:ext uri="{BB962C8B-B14F-4D97-AF65-F5344CB8AC3E}">
+        <p14:creationId xmlns:p14="http://schemas.microsoft.com/office/powerpoint/2010/main" val="3276420071"/>
+      </p:ext>
+    </p:extLst>
   </p:cSld>
   <p:clrMapOvr>
     <a:masterClrMapping/>
   </p:clrMapOvr>
   <p:transition spd="med"/>
-  <p:timing>
-    <p:tnLst>
-      <p:par>
-        <p:cTn id="1" dur="indefinite" restart="never" nodeType="tmRoot">
-          <p:childTnLst>
-            <p:seq concurrent="1" nextAc="seek">
-              <p:cTn id="2" dur="indefinite" nodeType="mainSeq">
-                <p:childTnLst>
-                  <p:par>
-                    <p:cTn id="3" fill="hold">
-                      <p:stCondLst>
-                        <p:cond delay="indefinite"/>
-                      </p:stCondLst>
-                      <p:childTnLst>
-                        <p:par>
-                          <p:cTn id="4" fill="hold">
-                            <p:stCondLst>
-                              <p:cond delay="0"/>
-                            </p:stCondLst>
-                            <p:childTnLst>
-                              <p:par>
-                                <p:cTn id="5" presetID="1" presetClass="entr" presetSubtype="0" fill="hold" nodeType="clickEffect">
-                                  <p:stCondLst>
-                                    <p:cond delay="0"/>
-                                  </p:stCondLst>
-                                  <p:childTnLst>
-                                    <p:set>
-                                      <p:cBhvr>
-                                        <p:cTn id="6" dur="1" fill="hold">
-                                          <p:stCondLst>
-                                            <p:cond delay="0"/>
-                                          </p:stCondLst>
-                                        </p:cTn>
-                                        <p:tgtEl>
-                                          <p:spTgt spid="241">
-                                            <p:txEl>
-                                              <p:pRg st="2" end="2"/>
-                                            </p:txEl>
-                                          </p:spTgt>
-                                        </p:tgtEl>
-                                        <p:attrNameLst>
-                                          <p:attrName>style.visibility</p:attrName>
-                                        </p:attrNameLst>
-                                      </p:cBhvr>
-                                      <p:to>
-                                        <p:strVal val="visible"/>
-                                      </p:to>
-                                    </p:set>
-                                  </p:childTnLst>
-                                </p:cTn>
-                              </p:par>
-                            </p:childTnLst>
-                          </p:cTn>
-                        </p:par>
-                      </p:childTnLst>
-                    </p:cTn>
-                  </p:par>
-                  <p:par>
-                    <p:cTn id="7" fill="hold">
-                      <p:stCondLst>
-                        <p:cond delay="indefinite"/>
-                      </p:stCondLst>
-                      <p:childTnLst>
-                        <p:par>
-                          <p:cTn id="8" fill="hold">
-                            <p:stCondLst>
-                              <p:cond delay="0"/>
-                            </p:stCondLst>
-                            <p:childTnLst>
-                              <p:par>
-                                <p:cTn id="9" presetID="1" presetClass="entr" presetSubtype="0" fill="hold" nodeType="clickEffect">
-                                  <p:stCondLst>
-                                    <p:cond delay="0"/>
-                                  </p:stCondLst>
-                                  <p:childTnLst>
-                                    <p:set>
-                                      <p:cBhvr>
-                                        <p:cTn id="10" dur="1" fill="hold">
-                                          <p:stCondLst>
-                                            <p:cond delay="0"/>
-                                          </p:stCondLst>
-                                        </p:cTn>
-                                        <p:tgtEl>
-                                          <p:spTgt spid="241">
-                                            <p:txEl>
-                                              <p:pRg st="3" end="3"/>
-                                            </p:txEl>
-                                          </p:spTgt>
-                                        </p:tgtEl>
-                                        <p:attrNameLst>
-                                          <p:attrName>style.visibility</p:attrName>
-                                        </p:attrNameLst>
-                                      </p:cBhvr>
-                                      <p:to>
-                                        <p:strVal val="visible"/>
-                                      </p:to>
-                                    </p:set>
-                                  </p:childTnLst>
-                                </p:cTn>
-                              </p:par>
-                            </p:childTnLst>
-                          </p:cTn>
-                        </p:par>
-                      </p:childTnLst>
-                    </p:cTn>
-                  </p:par>
-                </p:childTnLst>
-              </p:cTn>
-              <p:prevCondLst>
-                <p:cond evt="onPrev" delay="0">
-                  <p:tgtEl>
-                    <p:sldTgt/>
-                  </p:tgtEl>
-                </p:cond>
-              </p:prevCondLst>
-              <p:nextCondLst>
-                <p:cond evt="onNext" delay="0">
-                  <p:tgtEl>
-                    <p:sldTgt/>
-                  </p:tgtEl>
-                </p:cond>
-              </p:nextCondLst>
-            </p:seq>
-          </p:childTnLst>
-        </p:cTn>
-      </p:par>
-    </p:tnLst>
-  </p:timing>
 </p:sld>
 </file>
 
-<file path=ppt/slides/slide3.xml><?xml version="1.0" encoding="utf-8"?>
+<file path=ppt/slides/slide17.xml><?xml version="1.0" encoding="utf-8"?>
+<p:sld xmlns:a="http://schemas.openxmlformats.org/drawingml/2006/main" xmlns:r="http://schemas.openxmlformats.org/officeDocument/2006/relationships" xmlns:p="http://schemas.openxmlformats.org/presentationml/2006/main">
+  <p:cSld>
+    <p:spTree>
+      <p:nvGrpSpPr>
+        <p:cNvPr id="1" name=""/>
+        <p:cNvGrpSpPr/>
+        <p:nvPr/>
+      </p:nvGrpSpPr>
+      <p:grpSpPr>
+        <a:xfrm>
+          <a:off x="0" y="0"/>
+          <a:ext cx="0" cy="0"/>
+          <a:chOff x="0" y="0"/>
+          <a:chExt cx="0" cy="0"/>
+        </a:xfrm>
+      </p:grpSpPr>
+      <p:sp>
+        <p:nvSpPr>
+          <p:cNvPr id="314" name="Regularization"/>
+          <p:cNvSpPr txBox="1">
+            <a:spLocks noGrp="1"/>
+          </p:cNvSpPr>
+          <p:nvPr>
+            <p:ph type="title"/>
+          </p:nvPr>
+        </p:nvSpPr>
+        <p:spPr>
+          <a:prstGeom prst="rect">
+            <a:avLst/>
+          </a:prstGeom>
+        </p:spPr>
+        <p:txBody>
+          <a:bodyPr/>
+          <a:lstStyle/>
+          <a:p>
+            <a:r>
+              <a:rPr lang="en-US"/>
+              <a:t>Key Takeaways</a:t>
+            </a:r>
+            <a:endParaRPr/>
+          </a:p>
+        </p:txBody>
+      </p:sp>
+      <p:sp>
+        <p:nvSpPr>
+          <p:cNvPr id="315" name="We’ve just looked at Lasso, Ridge, and Elastic net (explicit regularization) in the context of linear regression…"/>
+          <p:cNvSpPr txBox="1">
+            <a:spLocks noGrp="1"/>
+          </p:cNvSpPr>
+          <p:nvPr>
+            <p:ph type="body" idx="1"/>
+          </p:nvPr>
+        </p:nvSpPr>
+        <p:spPr>
+          <a:prstGeom prst="rect">
+            <a:avLst/>
+          </a:prstGeom>
+        </p:spPr>
+        <p:txBody>
+          <a:bodyPr/>
+          <a:lstStyle/>
+          <a:p>
+            <a:r>
+              <a:rPr lang="en-US"/>
+              <a:t>Regularization is the dial that controls model complexity</a:t>
+            </a:r>
+          </a:p>
+          <a:p>
+            <a:r>
+              <a:rPr lang="en-US"/>
+              <a:t>Lasso: sparse coefficients, built-in variable selection</a:t>
+            </a:r>
+          </a:p>
+          <a:p>
+            <a:r>
+              <a:rPr lang="en-US"/>
+              <a:t>Ridge: stable shrinkage, handles correlated features</a:t>
+            </a:r>
+          </a:p>
+          <a:p>
+            <a:r>
+              <a:rPr lang="en-US"/>
+              <a:t>Elastic Net: the middle ground</a:t>
+            </a:r>
+          </a:p>
+          <a:p>
+            <a:r>
+              <a:rPr lang="en-US"/>
+              <a:t>Standardize first, then tune </a:t>
+            </a:r>
+            <a:r>
+              <a:rPr lang="el-GR"/>
+              <a:t>α </a:t>
+            </a:r>
+            <a:r>
+              <a:rPr lang="en-US"/>
+              <a:t>by cross-validation</a:t>
+            </a:r>
+            <a:endParaRPr/>
+          </a:p>
+        </p:txBody>
+      </p:sp>
+    </p:spTree>
+    <p:extLst>
+      <p:ext uri="{BB962C8B-B14F-4D97-AF65-F5344CB8AC3E}">
+        <p14:creationId xmlns:p14="http://schemas.microsoft.com/office/powerpoint/2010/main" val="502719297"/>
+      </p:ext>
+    </p:extLst>
+  </p:cSld>
+  <p:clrMapOvr>
+    <a:masterClrMapping/>
+  </p:clrMapOvr>
+  <p:transition spd="med"/>
+</p:sld>
+</file>
+
+<file path=ppt/slides/slide2.xml><?xml version="1.0" encoding="utf-8"?>
 <p:sld xmlns:a="http://schemas.openxmlformats.org/drawingml/2006/main" xmlns:r="http://schemas.openxmlformats.org/officeDocument/2006/relationships" xmlns:p="http://schemas.openxmlformats.org/presentationml/2006/main">
   <p:cSld>
     <p:spTree>
@@ -7479,6 +7448,116 @@
         <p14:creationId xmlns:p14="http://schemas.microsoft.com/office/powerpoint/2010/main" val="1886521451"/>
       </p:ext>
     </p:extLst>
+  </p:cSld>
+  <p:clrMapOvr>
+    <a:masterClrMapping/>
+  </p:clrMapOvr>
+  <p:transition spd="med"/>
+</p:sld>
+</file>
+
+<file path=ppt/slides/slide3.xml><?xml version="1.0" encoding="utf-8"?>
+<p:sld xmlns:a="http://schemas.openxmlformats.org/drawingml/2006/main" xmlns:r="http://schemas.openxmlformats.org/officeDocument/2006/relationships" xmlns:p="http://schemas.openxmlformats.org/presentationml/2006/main">
+  <p:cSld>
+    <p:spTree>
+      <p:nvGrpSpPr>
+        <p:cNvPr id="1" name=""/>
+        <p:cNvGrpSpPr/>
+        <p:nvPr/>
+      </p:nvGrpSpPr>
+      <p:grpSpPr>
+        <a:xfrm>
+          <a:off x="0" y="0"/>
+          <a:ext cx="0" cy="0"/>
+          <a:chOff x="0" y="0"/>
+          <a:chExt cx="0" cy="0"/>
+        </a:xfrm>
+      </p:grpSpPr>
+      <p:sp>
+        <p:nvSpPr>
+          <p:cNvPr id="240" name="Regularization"/>
+          <p:cNvSpPr txBox="1">
+            <a:spLocks noGrp="1"/>
+          </p:cNvSpPr>
+          <p:nvPr>
+            <p:ph type="title"/>
+          </p:nvPr>
+        </p:nvSpPr>
+        <p:spPr>
+          <a:prstGeom prst="rect">
+            <a:avLst/>
+          </a:prstGeom>
+        </p:spPr>
+        <p:txBody>
+          <a:bodyPr/>
+          <a:lstStyle/>
+          <a:p>
+            <a:r>
+              <a:t>Regularization</a:t>
+            </a:r>
+          </a:p>
+        </p:txBody>
+      </p:sp>
+      <p:sp>
+        <p:nvSpPr>
+          <p:cNvPr id="241" name="We said that adding constraints to model is a way to simplify the model to help prevent overfitting…"/>
+          <p:cNvSpPr txBox="1">
+            <a:spLocks noGrp="1"/>
+          </p:cNvSpPr>
+          <p:nvPr>
+            <p:ph type="body" idx="1"/>
+          </p:nvPr>
+        </p:nvSpPr>
+        <p:spPr>
+          <a:prstGeom prst="rect">
+            <a:avLst/>
+          </a:prstGeom>
+        </p:spPr>
+        <p:txBody>
+          <a:bodyPr/>
+          <a:lstStyle/>
+          <a:p>
+            <a:r>
+              <a:rPr lang="en-US" b="1"/>
+              <a:t>Regularization</a:t>
+            </a:r>
+            <a:r>
+              <a:rPr lang="en-US"/>
+              <a:t>: techniques that constrain a model to reduce overfitting and improve generalization</a:t>
+            </a:r>
+          </a:p>
+          <a:p>
+            <a:r>
+              <a:rPr lang="en-US"/>
+              <a:t>Two broad families:</a:t>
+            </a:r>
+          </a:p>
+          <a:p>
+            <a:pPr lvl="1"/>
+            <a:r>
+              <a:rPr lang="en-US" b="1"/>
+              <a:t>Explicit</a:t>
+            </a:r>
+            <a:r>
+              <a:rPr lang="en-US"/>
+              <a:t>  – add a penalty term directly to the loss function</a:t>
+            </a:r>
+          </a:p>
+          <a:p>
+            <a:pPr lvl="1"/>
+            <a:r>
+              <a:rPr lang="en-US" b="1"/>
+              <a:t>Implicit</a:t>
+            </a:r>
+            <a:r>
+              <a:rPr lang="en-US"/>
+              <a:t>  – constrain the model through the algorithm or training process</a:t>
+            </a:r>
+            <a:endParaRPr/>
+          </a:p>
+        </p:txBody>
+      </p:sp>
+    </p:spTree>
   </p:cSld>
   <p:clrMapOvr>
     <a:masterClrMapping/>
@@ -8018,8 +8097,10 @@
           <a:lstStyle/>
           <a:p>
             <a:r>
-              <a:t>Regularized Cost Functions</a:t>
-            </a:r>
+              <a:rPr lang="en-US"/>
+              <a:t>Least Squares: The Baseline</a:t>
+            </a:r>
+            <a:endParaRPr/>
           </a:p>
         </p:txBody>
       </p:sp>
@@ -8533,8 +8614,8 @@
           <a:chExt cx="0" cy="0"/>
         </a:xfrm>
       </p:grpSpPr>
-      <mc:AlternateContent xmlns:mc="http://schemas.openxmlformats.org/markup-compatibility/2006" xmlns:a14="http://schemas.microsoft.com/office/drawing/2010/main">
-        <mc:Choice Requires="a14">
+      <mc:AlternateContent xmlns:mc="http://schemas.openxmlformats.org/markup-compatibility/2006">
+        <mc:Choice xmlns:a14="http://schemas.microsoft.com/office/drawing/2010/main" Requires="a14">
           <p:sp>
             <p:nvSpPr>
               <p:cNvPr id="265" name="Least squares cost function…"/>
@@ -8559,17 +8640,15 @@
               <a:lstStyle/>
               <a:p>
                 <a:r>
-                  <a:rPr dirty="0"/>
                   <a:t>Least squares cost function </a:t>
                 </a:r>
-                <a:endParaRPr lang="en-US" dirty="0"/>
+                <a:endParaRPr lang="en-US"/>
               </a:p>
               <a:p>
                 <a:pPr marL="0" indent="0">
                   <a:buNone/>
                 </a:pPr>
                 <a:r>
-                  <a:rPr dirty="0"/>
                   <a:t>                    </a:t>
                 </a:r>
                 <a14:m>
@@ -8975,11 +9054,11 @@
                     </m:sSup>
                   </m:oMath>
                 </a14:m>
-                <a:endParaRPr dirty="0"/>
+                <a:endParaRPr/>
               </a:p>
               <a:p>
                 <a:r>
-                  <a:rPr b="1" u="sng" dirty="0">
+                  <a:rPr b="1" u="sng">
                     <a:latin typeface="Graphik"/>
                     <a:ea typeface="Graphik"/>
                     <a:cs typeface="Graphik"/>
@@ -8988,11 +9067,10 @@
                   <a:t>Lasso</a:t>
                 </a:r>
                 <a:r>
-                  <a:rPr dirty="0"/>
                   <a:t> linear regression cost function </a:t>
                 </a:r>
                 <a:br>
-                  <a:rPr dirty="0"/>
+                  <a:rPr/>
                 </a:br>
                 <a14:m>
                   <m:oMath xmlns:m="http://schemas.openxmlformats.org/officeDocument/2006/math">
@@ -9559,19 +9637,17 @@
                   </m:oMath>
                 </a14:m>
                 <a:r>
-                  <a:rPr lang="en-US" dirty="0"/>
+                  <a:rPr lang="en-US"/>
                   <a:t>,</a:t>
                 </a:r>
                 <a:r>
-                  <a:rPr dirty="0"/>
                   <a:t> </a:t>
                 </a:r>
                 <a:r>
-                  <a:rPr lang="en-US" dirty="0"/>
+                  <a:rPr lang="en-US"/>
                   <a:t>        </a:t>
                 </a:r>
                 <a:r>
-                  <a:rPr dirty="0"/>
                   <a:t>(</a:t>
                 </a:r>
                 <a14:m>
@@ -9597,10 +9673,9 @@
                   </m:oMath>
                 </a14:m>
                 <a:r>
-                  <a:rPr dirty="0"/>
                   <a:t>)</a:t>
                 </a:r>
-                <a:endParaRPr dirty="0">
+                <a:endParaRPr>
                   <a:solidFill>
                     <a:srgbClr val="53585F"/>
                   </a:solidFill>
@@ -9609,7 +9684,7 @@
             </p:txBody>
           </p:sp>
         </mc:Choice>
-        <mc:Fallback xmlns="">
+        <mc:Fallback>
           <p:sp>
             <p:nvSpPr>
               <p:cNvPr id="265" name="Least squares cost function…"/>
@@ -9631,7 +9706,7 @@
               <a:blipFill>
                 <a:blip r:embed="rId2"/>
                 <a:stretch>
-                  <a:fillRect l="-740" t="-576"/>
+                  <a:fillRect l="-605" t="-576"/>
                 </a:stretch>
               </a:blipFill>
             </p:spPr>
@@ -9650,8 +9725,8 @@
           </p:sp>
         </mc:Fallback>
       </mc:AlternateContent>
-      <mc:AlternateContent xmlns:mc="http://schemas.openxmlformats.org/markup-compatibility/2006" xmlns:a14="http://schemas.microsoft.com/office/drawing/2010/main">
-        <mc:Choice Requires="a14">
+      <mc:AlternateContent xmlns:mc="http://schemas.openxmlformats.org/markup-compatibility/2006">
+        <mc:Choice xmlns:a14="http://schemas.microsoft.com/office/drawing/2010/main" Requires="a14">
           <p:sp>
             <p:nvSpPr>
               <p:cNvPr id="266" name="Tries to fit the data well (find  s that move the prediction close to the observed data)"/>
@@ -9671,7 +9746,7 @@
               </a:ln>
               <a:extLst>
                 <a:ext uri="{C572A759-6A51-4108-AA02-DFA0A04FC94B}">
-                  <ma14:wrappingTextBoxFlag xmlns="" xmlns:m="http://schemas.openxmlformats.org/officeDocument/2006/math" xmlns:ma14="http://schemas.microsoft.com/office/mac/drawingml/2011/main" val="1"/>
+                  <ma14:wrappingTextBoxFlag xmlns:ma14="http://schemas.microsoft.com/office/mac/drawingml/2011/main" xmlns:m="http://schemas.openxmlformats.org/officeDocument/2006/math" xmlns="" val="1"/>
                 </a:ext>
               </a:extLst>
             </p:spPr>
@@ -9693,14 +9768,14 @@
                   </a:defRPr>
                 </a:pPr>
                 <a:r>
-                  <a:rPr sz="1266" dirty="0"/>
+                  <a:rPr sz="1266"/>
                   <a:t>Tries to fit the data well</a:t>
                 </a:r>
                 <a:br>
-                  <a:rPr sz="1266" dirty="0"/>
+                  <a:rPr sz="1266"/>
                 </a:br>
                 <a:r>
-                  <a:rPr sz="1617" dirty="0"/>
+                  <a:rPr sz="1617"/>
                   <a:t>(find </a:t>
                 </a:r>
                 <a14:m>
@@ -9717,14 +9792,14 @@
                   </m:oMath>
                 </a14:m>
                 <a:r>
-                  <a:rPr sz="1617" dirty="0"/>
+                  <a:rPr sz="1617"/>
                   <a:t>s that move the prediction close to the observed data)</a:t>
                 </a:r>
               </a:p>
             </p:txBody>
           </p:sp>
         </mc:Choice>
-        <mc:Fallback xmlns="">
+        <mc:Fallback>
           <p:sp>
             <p:nvSpPr>
               <p:cNvPr id="266" name="Tries to fit the data well (find  s that move the prediction close to the observed data)"/>
@@ -9744,7 +9819,7 @@
               <a:blipFill>
                 <a:blip r:embed="rId3"/>
                 <a:stretch>
-                  <a:fillRect l="-3086" t="-800" r="-617" b="-12000"/>
+                  <a:fillRect l="-3086" t="-800" r="-206" b="-12000"/>
                 </a:stretch>
               </a:blipFill>
               <a:ln w="3175">
@@ -9752,7 +9827,7 @@
               </a:ln>
               <a:extLst>
                 <a:ext uri="{C572A759-6A51-4108-AA02-DFA0A04FC94B}">
-                  <ma14:wrappingTextBoxFlag xmlns="" xmlns:m="http://schemas.openxmlformats.org/officeDocument/2006/math" xmlns:ma14="http://schemas.microsoft.com/office/mac/drawingml/2011/main" xmlns:a14="http://schemas.microsoft.com/office/drawing/2010/main" val="1"/>
+                  <ma14:wrappingTextBoxFlag xmlns:a14="http://schemas.microsoft.com/office/drawing/2010/main" xmlns:ma14="http://schemas.microsoft.com/office/mac/drawingml/2011/main" xmlns:m="http://schemas.openxmlformats.org/officeDocument/2006/math" xmlns="" val="1"/>
                 </a:ext>
               </a:extLst>
             </p:spPr>
@@ -9787,8 +9862,8 @@
         </p:blipFill>
         <p:spPr>
           <a:xfrm>
-            <a:off x="3977690" y="5167447"/>
-            <a:ext cx="2960401" cy="101029"/>
+            <a:off x="4060323" y="5167447"/>
+            <a:ext cx="2795135" cy="101029"/>
           </a:xfrm>
           <a:prstGeom prst="rect">
             <a:avLst/>
@@ -9811,8 +9886,8 @@
         </p:blipFill>
         <p:spPr>
           <a:xfrm>
-            <a:off x="7895188" y="5098753"/>
-            <a:ext cx="1065748" cy="101029"/>
+            <a:off x="7922917" y="5098753"/>
+            <a:ext cx="1010290" cy="101029"/>
           </a:xfrm>
           <a:prstGeom prst="rect">
             <a:avLst/>
@@ -9835,16 +9910,16 @@
         </p:blipFill>
         <p:spPr>
           <a:xfrm>
-            <a:off x="7544374" y="4795265"/>
-            <a:ext cx="350814" cy="101029"/>
+            <a:off x="7551399" y="4795265"/>
+            <a:ext cx="336763" cy="101029"/>
           </a:xfrm>
           <a:prstGeom prst="rect">
             <a:avLst/>
           </a:prstGeom>
         </p:spPr>
       </p:pic>
-      <mc:AlternateContent xmlns:mc="http://schemas.openxmlformats.org/markup-compatibility/2006" xmlns:a14="http://schemas.microsoft.com/office/drawing/2010/main">
-        <mc:Choice Requires="a14">
+      <mc:AlternateContent xmlns:mc="http://schemas.openxmlformats.org/markup-compatibility/2006">
+        <mc:Choice xmlns:a14="http://schemas.microsoft.com/office/drawing/2010/main" Requires="a14">
           <p:sp>
             <p:nvSpPr>
               <p:cNvPr id="273" name="Constrains the model (pushes  s to be close to or exactly equal to 0)"/>
@@ -9864,7 +9939,7 @@
               </a:ln>
               <a:extLst>
                 <a:ext uri="{C572A759-6A51-4108-AA02-DFA0A04FC94B}">
-                  <ma14:wrappingTextBoxFlag xmlns="" xmlns:m="http://schemas.openxmlformats.org/officeDocument/2006/math" xmlns:ma14="http://schemas.microsoft.com/office/mac/drawingml/2011/main" val="1"/>
+                  <ma14:wrappingTextBoxFlag xmlns:ma14="http://schemas.microsoft.com/office/mac/drawingml/2011/main" xmlns:m="http://schemas.openxmlformats.org/officeDocument/2006/math" xmlns="" val="1"/>
                 </a:ext>
               </a:extLst>
             </p:spPr>
@@ -9917,7 +9992,7 @@
             </p:txBody>
           </p:sp>
         </mc:Choice>
-        <mc:Fallback xmlns="">
+        <mc:Fallback>
           <p:sp>
             <p:nvSpPr>
               <p:cNvPr id="273" name="Constrains the model (pushes  s to be close to or exactly equal to 0)"/>
@@ -9945,7 +10020,7 @@
               </a:ln>
               <a:extLst>
                 <a:ext uri="{C572A759-6A51-4108-AA02-DFA0A04FC94B}">
-                  <ma14:wrappingTextBoxFlag xmlns="" xmlns:m="http://schemas.openxmlformats.org/officeDocument/2006/math" xmlns:ma14="http://schemas.microsoft.com/office/mac/drawingml/2011/main" xmlns:a14="http://schemas.microsoft.com/office/drawing/2010/main" val="1"/>
+                  <ma14:wrappingTextBoxFlag xmlns:a14="http://schemas.microsoft.com/office/drawing/2010/main" xmlns:ma14="http://schemas.microsoft.com/office/mac/drawingml/2011/main" xmlns:m="http://schemas.openxmlformats.org/officeDocument/2006/math" xmlns="" val="1"/>
                 </a:ext>
               </a:extLst>
             </p:spPr>
@@ -9983,7 +10058,7 @@
           </a:ln>
           <a:extLst>
             <a:ext uri="{C572A759-6A51-4108-AA02-DFA0A04FC94B}">
-              <ma14:wrappingTextBoxFlag xmlns="" xmlns:m="http://schemas.openxmlformats.org/officeDocument/2006/math" xmlns:a14="http://schemas.microsoft.com/office/drawing/2010/main" xmlns:ma14="http://schemas.microsoft.com/office/mac/drawingml/2011/main" val="1"/>
+              <ma14:wrappingTextBoxFlag xmlns:ma14="http://schemas.microsoft.com/office/mac/drawingml/2011/main" xmlns:a14="http://schemas.microsoft.com/office/drawing/2010/main" xmlns:m="http://schemas.openxmlformats.org/officeDocument/2006/math" xmlns="" val="1"/>
             </a:ext>
           </a:extLst>
         </p:spPr>
@@ -10006,7 +10081,7 @@
           </a:lstStyle>
           <a:p>
             <a:r>
-              <a:rPr sz="1266" dirty="0"/>
+              <a:rPr sz="1266"/>
               <a:t>Tuning parameter that controls relative impact of two criteria</a:t>
             </a:r>
           </a:p>
@@ -10028,16 +10103,16 @@
         </p:blipFill>
         <p:spPr>
           <a:xfrm rot="6013359">
-            <a:off x="7238047" y="3698900"/>
-            <a:ext cx="1314283" cy="286921"/>
+            <a:off x="7238047" y="3721661"/>
+            <a:ext cx="1314283" cy="241398"/>
           </a:xfrm>
           <a:prstGeom prst="rect">
             <a:avLst/>
           </a:prstGeom>
         </p:spPr>
       </p:pic>
-      <mc:AlternateContent xmlns:mc="http://schemas.openxmlformats.org/markup-compatibility/2006" xmlns:a14="http://schemas.microsoft.com/office/drawing/2010/main">
-        <mc:Choice Requires="a14">
+      <mc:AlternateContent xmlns:mc="http://schemas.openxmlformats.org/markup-compatibility/2006">
+        <mc:Choice xmlns:a14="http://schemas.microsoft.com/office/drawing/2010/main" Requires="a14">
           <p:sp>
             <p:nvSpPr>
               <p:cNvPr id="277" name="What happens if   or  ?"/>
@@ -10057,7 +10132,7 @@
               </a:ln>
               <a:extLst>
                 <a:ext uri="{C572A759-6A51-4108-AA02-DFA0A04FC94B}">
-                  <ma14:wrappingTextBoxFlag xmlns="" xmlns:m="http://schemas.openxmlformats.org/officeDocument/2006/math" xmlns:ma14="http://schemas.microsoft.com/office/mac/drawingml/2011/main" val="1"/>
+                  <ma14:wrappingTextBoxFlag xmlns:ma14="http://schemas.microsoft.com/office/mac/drawingml/2011/main" xmlns:m="http://schemas.openxmlformats.org/officeDocument/2006/math" xmlns="" val="1"/>
                 </a:ext>
               </a:extLst>
             </p:spPr>
@@ -10079,7 +10154,7 @@
                   </a:defRPr>
                 </a:pPr>
                 <a:r>
-                  <a:rPr sz="1617" dirty="0"/>
+                  <a:rPr sz="1617"/>
                   <a:t>What happens if </a:t>
                 </a:r>
                 <a14:m>
@@ -10105,7 +10180,7 @@
                   </m:oMath>
                 </a14:m>
                 <a:r>
-                  <a:rPr sz="1617" dirty="0"/>
+                  <a:rPr sz="1617"/>
                   <a:t> or </a:t>
                 </a:r>
                 <a14:m>
@@ -10131,14 +10206,14 @@
                   </m:oMath>
                 </a14:m>
                 <a:r>
-                  <a:rPr sz="1617" dirty="0"/>
+                  <a:rPr sz="1617"/>
                   <a:t>?</a:t>
                 </a:r>
               </a:p>
             </p:txBody>
           </p:sp>
         </mc:Choice>
-        <mc:Fallback xmlns="">
+        <mc:Fallback>
           <p:sp>
             <p:nvSpPr>
               <p:cNvPr id="277" name="What happens if   or  ?"/>
@@ -10166,7 +10241,7 @@
               </a:ln>
               <a:extLst>
                 <a:ext uri="{C572A759-6A51-4108-AA02-DFA0A04FC94B}">
-                  <ma14:wrappingTextBoxFlag xmlns="" xmlns:m="http://schemas.openxmlformats.org/officeDocument/2006/math" xmlns:ma14="http://schemas.microsoft.com/office/mac/drawingml/2011/main" xmlns:a14="http://schemas.microsoft.com/office/drawing/2010/main" val="1"/>
+                  <ma14:wrappingTextBoxFlag xmlns:a14="http://schemas.microsoft.com/office/drawing/2010/main" xmlns:ma14="http://schemas.microsoft.com/office/mac/drawingml/2011/main" xmlns:m="http://schemas.openxmlformats.org/officeDocument/2006/math" xmlns="" val="1"/>
                 </a:ext>
               </a:extLst>
             </p:spPr>
@@ -10214,7 +10289,7 @@
           <a:lstStyle/>
           <a:p>
             <a:r>
-              <a:rPr lang="en-US" dirty="0"/>
+              <a:rPr lang="en-US"/>
               <a:t>L1 Penalty: LASSO</a:t>
             </a:r>
           </a:p>
@@ -10646,14 +10721,15 @@
           <a:lstStyle/>
           <a:p>
             <a:r>
-              <a:rPr dirty="0"/>
-              <a:t>Regularized Cost Functions</a:t>
-            </a:r>
+              <a:rPr lang="en-US"/>
+              <a:t>ℓ1 vs ℓ2 Penalties</a:t>
+            </a:r>
+            <a:endParaRPr/>
           </a:p>
         </p:txBody>
       </p:sp>
-      <mc:AlternateContent xmlns:mc="http://schemas.openxmlformats.org/markup-compatibility/2006" xmlns:a14="http://schemas.microsoft.com/office/drawing/2010/main">
-        <mc:Choice Requires="a14">
+      <mc:AlternateContent xmlns:mc="http://schemas.openxmlformats.org/markup-compatibility/2006">
+        <mc:Choice xmlns:a14="http://schemas.microsoft.com/office/drawing/2010/main" Requires="a14">
           <p:sp>
             <p:nvSpPr>
               <p:cNvPr id="281" name="Lasso linear regression cost function    (where  )…"/>
@@ -10678,7 +10754,7 @@
               <a:lstStyle/>
               <a:p>
                 <a:r>
-                  <a:rPr b="1" u="sng" dirty="0">
+                  <a:rPr b="1" u="sng">
                     <a:latin typeface="Graphik"/>
                     <a:ea typeface="Graphik"/>
                     <a:cs typeface="Graphik"/>
@@ -10687,11 +10763,10 @@
                   <a:t>Lasso</a:t>
                 </a:r>
                 <a:r>
-                  <a:rPr dirty="0"/>
                   <a:t> linear regression cost function </a:t>
                 </a:r>
                 <a:br>
-                  <a:rPr dirty="0"/>
+                  <a:rPr/>
                 </a:br>
                 <a14:m>
                   <m:oMath xmlns:m="http://schemas.openxmlformats.org/officeDocument/2006/math">
@@ -11258,11 +11333,10 @@
                   </m:oMath>
                 </a14:m>
                 <a:r>
-                  <a:rPr lang="en-US" dirty="0"/>
+                  <a:rPr lang="en-US"/>
                   <a:t>,  </a:t>
                 </a:r>
                 <a:r>
-                  <a:rPr dirty="0"/>
                   <a:t> (where </a:t>
                 </a:r>
                 <a14:m>
@@ -11288,13 +11362,12 @@
                   </m:oMath>
                 </a14:m>
                 <a:r>
-                  <a:rPr dirty="0"/>
                   <a:t>)</a:t>
                 </a:r>
               </a:p>
               <a:p>
                 <a:r>
-                  <a:rPr b="1" u="sng" dirty="0">
+                  <a:rPr b="1" u="sng">
                     <a:latin typeface="Graphik"/>
                     <a:ea typeface="Graphik"/>
                     <a:cs typeface="Graphik"/>
@@ -11303,11 +11376,10 @@
                   <a:t>Ridge</a:t>
                 </a:r>
                 <a:r>
-                  <a:rPr dirty="0"/>
                   <a:t> linear regression cost function </a:t>
                 </a:r>
                 <a:br>
-                  <a:rPr dirty="0"/>
+                  <a:rPr/>
                 </a:br>
                 <a14:m>
                   <m:oMath xmlns:m="http://schemas.openxmlformats.org/officeDocument/2006/math">
@@ -11906,7 +11978,6 @@
                   </m:oMath>
                 </a14:m>
                 <a:r>
-                  <a:rPr dirty="0"/>
                   <a:t> (where </a:t>
                 </a:r>
                 <a14:m>
@@ -11932,10 +12003,9 @@
                   </m:oMath>
                 </a14:m>
                 <a:r>
-                  <a:rPr dirty="0"/>
                   <a:t>)</a:t>
                 </a:r>
-                <a:endParaRPr dirty="0">
+                <a:endParaRPr>
                   <a:solidFill>
                     <a:srgbClr val="53585F"/>
                   </a:solidFill>
@@ -11944,7 +12014,7 @@
             </p:txBody>
           </p:sp>
         </mc:Choice>
-        <mc:Fallback xmlns="">
+        <mc:Fallback>
           <p:sp>
             <p:nvSpPr>
               <p:cNvPr id="281" name="Lasso linear regression cost function    (where  )…"/>
@@ -12004,7 +12074,7 @@
           </a:ln>
           <a:extLst>
             <a:ext uri="{C572A759-6A51-4108-AA02-DFA0A04FC94B}">
-              <ma14:wrappingTextBoxFlag xmlns="" xmlns:m="http://schemas.openxmlformats.org/officeDocument/2006/math" xmlns:a14="http://schemas.microsoft.com/office/drawing/2010/main" xmlns:ma14="http://schemas.microsoft.com/office/mac/drawingml/2011/main" val="1"/>
+              <ma14:wrappingTextBoxFlag xmlns:ma14="http://schemas.microsoft.com/office/mac/drawingml/2011/main" xmlns:a14="http://schemas.microsoft.com/office/drawing/2010/main" xmlns:m="http://schemas.openxmlformats.org/officeDocument/2006/math" xmlns="" val="1"/>
             </a:ext>
           </a:extLst>
         </p:spPr>
@@ -12026,15 +12096,15 @@
               </a:defRPr>
             </a:pPr>
             <a:r>
-              <a:rPr sz="2109" dirty="0"/>
+              <a:rPr sz="2109"/>
               <a:t>ℓ</a:t>
             </a:r>
             <a:r>
-              <a:rPr sz="2109" baseline="-5999" dirty="0"/>
+              <a:rPr sz="2109" baseline="-5999"/>
               <a:t>1</a:t>
             </a:r>
             <a:r>
-              <a:rPr sz="2109" dirty="0"/>
+              <a:rPr sz="2109"/>
               <a:t> penalty</a:t>
             </a:r>
           </a:p>
@@ -12059,7 +12129,7 @@
           </a:ln>
           <a:extLst>
             <a:ext uri="{C572A759-6A51-4108-AA02-DFA0A04FC94B}">
-              <ma14:wrappingTextBoxFlag xmlns="" xmlns:m="http://schemas.openxmlformats.org/officeDocument/2006/math" xmlns:a14="http://schemas.microsoft.com/office/drawing/2010/main" xmlns:ma14="http://schemas.microsoft.com/office/mac/drawingml/2011/main" val="1"/>
+              <ma14:wrappingTextBoxFlag xmlns:ma14="http://schemas.microsoft.com/office/mac/drawingml/2011/main" xmlns:a14="http://schemas.microsoft.com/office/drawing/2010/main" xmlns:m="http://schemas.openxmlformats.org/officeDocument/2006/math" xmlns="" val="1"/>
             </a:ext>
           </a:extLst>
         </p:spPr>
@@ -12081,15 +12151,15 @@
               </a:defRPr>
             </a:pPr>
             <a:r>
-              <a:rPr sz="2109" dirty="0"/>
+              <a:rPr sz="2109"/>
               <a:t>ℓ</a:t>
             </a:r>
             <a:r>
-              <a:rPr sz="2109" baseline="-5999" dirty="0"/>
+              <a:rPr sz="2109" baseline="-5999"/>
               <a:t>2</a:t>
             </a:r>
             <a:r>
-              <a:rPr sz="2109" dirty="0"/>
+              <a:rPr sz="2109"/>
               <a:t> penalty</a:t>
             </a:r>
           </a:p>
@@ -12117,16 +12187,16 @@
         </p:blipFill>
         <p:spPr>
           <a:xfrm>
-            <a:off x="7808222" y="4990915"/>
-            <a:ext cx="1065748" cy="101029"/>
+            <a:off x="7835951" y="4990915"/>
+            <a:ext cx="1010290" cy="101029"/>
           </a:xfrm>
           <a:prstGeom prst="rect">
             <a:avLst/>
           </a:prstGeom>
         </p:spPr>
       </p:pic>
-      <mc:AlternateContent xmlns:mc="http://schemas.openxmlformats.org/markup-compatibility/2006" xmlns:a14="http://schemas.microsoft.com/office/drawing/2010/main">
-        <mc:Choice Requires="a14">
+      <mc:AlternateContent xmlns:mc="http://schemas.openxmlformats.org/markup-compatibility/2006">
+        <mc:Choice xmlns:a14="http://schemas.microsoft.com/office/drawing/2010/main" Requires="a14">
           <p:sp>
             <p:nvSpPr>
               <p:cNvPr id="5" name="Constrains the model (pushes  s to be close to but NOT exactly equal to 0)">
@@ -12152,7 +12222,7 @@
               </a:ln>
               <a:extLst>
                 <a:ext uri="{C572A759-6A51-4108-AA02-DFA0A04FC94B}">
-                  <ma14:wrappingTextBoxFlag xmlns="" xmlns:m="http://schemas.openxmlformats.org/officeDocument/2006/math" xmlns:ma14="http://schemas.microsoft.com/office/mac/drawingml/2011/main" val="1"/>
+                  <ma14:wrappingTextBoxFlag xmlns:ma14="http://schemas.microsoft.com/office/mac/drawingml/2011/main" xmlns:m="http://schemas.openxmlformats.org/officeDocument/2006/math" xmlns="" val="1"/>
                 </a:ext>
               </a:extLst>
             </p:spPr>
@@ -12205,7 +12275,7 @@
             </p:txBody>
           </p:sp>
         </mc:Choice>
-        <mc:Fallback xmlns="">
+        <mc:Fallback>
           <p:sp>
             <p:nvSpPr>
               <p:cNvPr id="5" name="Constrains the model (pushes  s to be close to but NOT exactly equal to 0)">
@@ -12231,7 +12301,7 @@
               <a:blipFill>
                 <a:blip r:embed="rId4"/>
                 <a:stretch>
-                  <a:fillRect l="-3093" t="-800" r="-2474" b="-12000"/>
+                  <a:fillRect l="-3093" t="-800" r="-2268" b="-12000"/>
                 </a:stretch>
               </a:blipFill>
               <a:ln w="3175">
@@ -12239,7 +12309,7 @@
               </a:ln>
               <a:extLst>
                 <a:ext uri="{C572A759-6A51-4108-AA02-DFA0A04FC94B}">
-                  <ma14:wrappingTextBoxFlag xmlns="" xmlns:m="http://schemas.openxmlformats.org/officeDocument/2006/math" xmlns:ma14="http://schemas.microsoft.com/office/mac/drawingml/2011/main" xmlns:a14="http://schemas.microsoft.com/office/drawing/2010/main" val="1"/>
+                  <ma14:wrappingTextBoxFlag xmlns:a14="http://schemas.microsoft.com/office/drawing/2010/main" xmlns:ma14="http://schemas.microsoft.com/office/mac/drawingml/2011/main" xmlns:m="http://schemas.openxmlformats.org/officeDocument/2006/math" xmlns="" val="1"/>
                 </a:ext>
               </a:extLst>
             </p:spPr>

</xml_diff>